<commit_message>
Add simulation graphs to reunion_prochaine.pptx
Embedded: Figure3_simulation (rat model), Figure4_Q21D_x2 (human),
Figure4_VPC_AUC5 (VPC population), Figure4c_grades_AUC5 (NCI grades).

https://claude.ai/code/session_01GxFodoNdE8EwfQNaex4rq6
</commit_message>
<xml_diff>
--- a/reunion_point/reunion_prochaine.pptx
+++ b/reunion_point/reunion_prochaine.pptx
@@ -4187,7 +4187,7 @@
         <p:spPr>
           <a:xfrm>
             <a:off x="365760" y="1417320"/>
-            <a:ext cx="5486400" cy="365760"/>
+            <a:ext cx="5029200" cy="365760"/>
           </a:xfrm>
           <a:prstGeom prst="rect">
             <a:avLst/>
@@ -4202,7 +4202,7 @@
           <a:p>
             <a:pPr algn="l"/>
             <a:r>
-              <a:rPr sz="1400" b="1">
+              <a:rPr sz="1300" b="1">
                 <a:solidFill>
                   <a:srgbClr val="00336B"/>
                 </a:solidFill>
@@ -4221,7 +4221,7 @@
         <p:spPr>
           <a:xfrm>
             <a:off x="365760" y="1874519"/>
-            <a:ext cx="2011680" cy="502920"/>
+            <a:ext cx="1828800" cy="457200"/>
           </a:xfrm>
           <a:prstGeom prst="rect">
             <a:avLst/>
@@ -4263,8 +4263,8 @@
         </p:nvSpPr>
         <p:spPr>
           <a:xfrm>
-            <a:off x="457200" y="1965959"/>
-            <a:ext cx="1828800" cy="347472"/>
+            <a:off x="457200" y="1947671"/>
+            <a:ext cx="1691640" cy="320040"/>
           </a:xfrm>
           <a:prstGeom prst="rect">
             <a:avLst/>
@@ -4279,7 +4279,7 @@
           <a:p>
             <a:pPr algn="l"/>
             <a:r>
-              <a:rPr sz="1200" b="1">
+              <a:rPr sz="1100" b="1">
                 <a:solidFill>
                   <a:srgbClr val="FFFFFF"/>
                 </a:solidFill>
@@ -4297,8 +4297,8 @@
         </p:nvSpPr>
         <p:spPr>
           <a:xfrm>
-            <a:off x="2514600" y="1965959"/>
-            <a:ext cx="8686800" cy="365760"/>
+            <a:off x="2286000" y="1947671"/>
+            <a:ext cx="2926080" cy="347472"/>
           </a:xfrm>
           <a:prstGeom prst="rect">
             <a:avLst/>
@@ -4313,12 +4313,12 @@
           <a:p>
             <a:pPr algn="l"/>
             <a:r>
-              <a:rPr sz="1200" b="0">
+              <a:rPr sz="1100" b="0">
                 <a:solidFill>
                   <a:srgbClr val="00336B"/>
                 </a:solidFill>
               </a:rPr>
-              <a:t>MPP → CMP → MEP (hiérarchie hématopoïétique complète)</a:t>
+              <a:t>MPP → CMP → MEP</a:t>
             </a:r>
           </a:p>
         </p:txBody>
@@ -4331,8 +4331,8 @@
         </p:nvSpPr>
         <p:spPr>
           <a:xfrm>
-            <a:off x="365760" y="2560319"/>
-            <a:ext cx="2011680" cy="502920"/>
+            <a:off x="365760" y="2514599"/>
+            <a:ext cx="1828800" cy="457200"/>
           </a:xfrm>
           <a:prstGeom prst="rect">
             <a:avLst/>
@@ -4374,8 +4374,8 @@
         </p:nvSpPr>
         <p:spPr>
           <a:xfrm>
-            <a:off x="457200" y="2651759"/>
-            <a:ext cx="1828800" cy="347472"/>
+            <a:off x="457200" y="2587751"/>
+            <a:ext cx="1691640" cy="320040"/>
           </a:xfrm>
           <a:prstGeom prst="rect">
             <a:avLst/>
@@ -4390,7 +4390,7 @@
           <a:p>
             <a:pPr algn="l"/>
             <a:r>
-              <a:rPr sz="1200" b="1">
+              <a:rPr sz="1100" b="1">
                 <a:solidFill>
                   <a:srgbClr val="FFFFFF"/>
                 </a:solidFill>
@@ -4408,8 +4408,8 @@
         </p:nvSpPr>
         <p:spPr>
           <a:xfrm>
-            <a:off x="2514600" y="2651759"/>
-            <a:ext cx="8686800" cy="365760"/>
+            <a:off x="2286000" y="2587751"/>
+            <a:ext cx="2926080" cy="347472"/>
           </a:xfrm>
           <a:prstGeom prst="rect">
             <a:avLst/>
@@ -4424,7 +4424,7 @@
           <a:p>
             <a:pPr algn="l"/>
             <a:r>
-              <a:rPr sz="1200" b="0">
+              <a:rPr sz="1100" b="0">
                 <a:solidFill>
                   <a:srgbClr val="00336B"/>
                 </a:solidFill>
@@ -4442,8 +4442,8 @@
         </p:nvSpPr>
         <p:spPr>
           <a:xfrm>
-            <a:off x="365760" y="3246119"/>
-            <a:ext cx="2011680" cy="502920"/>
+            <a:off x="365760" y="3154679"/>
+            <a:ext cx="1828800" cy="457200"/>
           </a:xfrm>
           <a:prstGeom prst="rect">
             <a:avLst/>
@@ -4485,8 +4485,8 @@
         </p:nvSpPr>
         <p:spPr>
           <a:xfrm>
-            <a:off x="457200" y="3337559"/>
-            <a:ext cx="1828800" cy="347472"/>
+            <a:off x="457200" y="3227831"/>
+            <a:ext cx="1691640" cy="320040"/>
           </a:xfrm>
           <a:prstGeom prst="rect">
             <a:avLst/>
@@ -4501,7 +4501,7 @@
           <a:p>
             <a:pPr algn="l"/>
             <a:r>
-              <a:rPr sz="1200" b="1">
+              <a:rPr sz="1100" b="1">
                 <a:solidFill>
                   <a:srgbClr val="FFFFFF"/>
                 </a:solidFill>
@@ -4519,8 +4519,8 @@
         </p:nvSpPr>
         <p:spPr>
           <a:xfrm>
-            <a:off x="2514600" y="3337559"/>
-            <a:ext cx="8686800" cy="365760"/>
+            <a:off x="2286000" y="3227831"/>
+            <a:ext cx="2926080" cy="347472"/>
           </a:xfrm>
           <a:prstGeom prst="rect">
             <a:avLst/>
@@ -4535,12 +4535,12 @@
           <a:p>
             <a:pPr algn="l"/>
             <a:r>
-              <a:rPr sz="1200" b="0">
+              <a:rPr sz="1100" b="0">
                 <a:solidFill>
                   <a:srgbClr val="00336B"/>
                 </a:solidFill>
               </a:rPr>
-              <a:t>Réticulocytes  +  Globules rouges</a:t>
+              <a:t>Réticulocytes  +  GR</a:t>
             </a:r>
           </a:p>
         </p:txBody>
@@ -4553,8 +4553,8 @@
         </p:nvSpPr>
         <p:spPr>
           <a:xfrm>
-            <a:off x="365760" y="3931919"/>
-            <a:ext cx="2011680" cy="502920"/>
+            <a:off x="365760" y="3794759"/>
+            <a:ext cx="1828800" cy="457200"/>
           </a:xfrm>
           <a:prstGeom prst="rect">
             <a:avLst/>
@@ -4596,8 +4596,8 @@
         </p:nvSpPr>
         <p:spPr>
           <a:xfrm>
-            <a:off x="457200" y="4023359"/>
-            <a:ext cx="1828800" cy="347472"/>
+            <a:off x="457200" y="3867911"/>
+            <a:ext cx="1691640" cy="320040"/>
           </a:xfrm>
           <a:prstGeom prst="rect">
             <a:avLst/>
@@ -4612,7 +4612,7 @@
           <a:p>
             <a:pPr algn="l"/>
             <a:r>
-              <a:rPr sz="1200" b="1">
+              <a:rPr sz="1100" b="1">
                 <a:solidFill>
                   <a:srgbClr val="FFFFFF"/>
                 </a:solidFill>
@@ -4630,8 +4630,8 @@
         </p:nvSpPr>
         <p:spPr>
           <a:xfrm>
-            <a:off x="2514600" y="4023359"/>
-            <a:ext cx="8686800" cy="365760"/>
+            <a:off x="2286000" y="3867911"/>
+            <a:ext cx="2926080" cy="347472"/>
           </a:xfrm>
           <a:prstGeom prst="rect">
             <a:avLst/>
@@ -4646,7 +4646,7 @@
           <a:p>
             <a:pPr algn="l"/>
             <a:r>
-              <a:rPr sz="1200" b="0">
+              <a:rPr sz="1100" b="0">
                 <a:solidFill>
                   <a:srgbClr val="00336B"/>
                 </a:solidFill>
@@ -4658,57 +4658,14 @@
       </p:sp>
       <p:sp>
         <p:nvSpPr>
-          <p:cNvPr id="20" name="Rectangle 19"/>
-          <p:cNvSpPr/>
-          <p:nvPr/>
-        </p:nvSpPr>
-        <p:spPr>
-          <a:xfrm>
-            <a:off x="365760" y="4754880"/>
-            <a:ext cx="11430000" cy="36576"/>
-          </a:xfrm>
-          <a:prstGeom prst="rect">
-            <a:avLst/>
-          </a:prstGeom>
-          <a:solidFill>
-            <a:srgbClr val="007AC2"/>
-          </a:solidFill>
-          <a:ln>
-            <a:noFill/>
-          </a:ln>
-        </p:spPr>
-        <p:style>
-          <a:lnRef idx="1">
-            <a:schemeClr val="accent1"/>
-          </a:lnRef>
-          <a:fillRef idx="3">
-            <a:schemeClr val="accent1"/>
-          </a:fillRef>
-          <a:effectRef idx="2">
-            <a:schemeClr val="accent1"/>
-          </a:effectRef>
-          <a:fontRef idx="minor">
-            <a:schemeClr val="lt1"/>
-          </a:fontRef>
-        </p:style>
-        <p:txBody>
-          <a:bodyPr rtlCol="0" anchor="ctr"/>
-          <a:lstStyle/>
-          <a:p>
-            <a:pPr algn="ctr"/>
-          </a:p>
-        </p:txBody>
-      </p:sp>
-      <p:sp>
-        <p:nvSpPr>
-          <p:cNvPr id="21" name="TextBox 20"/>
+          <p:cNvPr id="20" name="TextBox 19"/>
           <p:cNvSpPr txBox="1"/>
           <p:nvPr/>
         </p:nvSpPr>
         <p:spPr>
           <a:xfrm>
-            <a:off x="365760" y="4846320"/>
-            <a:ext cx="3657600" cy="365760"/>
+            <a:off x="365760" y="4572000"/>
+            <a:ext cx="5029200" cy="347472"/>
           </a:xfrm>
           <a:prstGeom prst="rect">
             <a:avLst/>
@@ -4723,26 +4680,26 @@
           <a:p>
             <a:pPr algn="l"/>
             <a:r>
-              <a:rPr sz="1400" b="1">
-                <a:solidFill>
-                  <a:srgbClr val="00336B"/>
+              <a:rPr sz="1100" b="0">
+                <a:solidFill>
+                  <a:srgbClr val="115511"/>
                 </a:solidFill>
               </a:rPr>
-              <a:t>Résultats clés</a:t>
-            </a:r>
-          </a:p>
-        </p:txBody>
-      </p:sp>
-      <p:sp>
-        <p:nvSpPr>
-          <p:cNvPr id="22" name="TextBox 21"/>
+              <a:t>✔  Oscillations cycliques reproduites</a:t>
+            </a:r>
+          </a:p>
+        </p:txBody>
+      </p:sp>
+      <p:sp>
+        <p:nvSpPr>
+          <p:cNvPr id="21" name="TextBox 20"/>
           <p:cNvSpPr txBox="1"/>
           <p:nvPr/>
         </p:nvSpPr>
         <p:spPr>
           <a:xfrm>
-            <a:off x="457200" y="5303520"/>
-            <a:ext cx="10972800" cy="256032"/>
+            <a:off x="365760" y="4937760"/>
+            <a:ext cx="5029200" cy="347472"/>
           </a:xfrm>
           <a:prstGeom prst="rect">
             <a:avLst/>
@@ -4757,26 +4714,26 @@
           <a:p>
             <a:pPr algn="l"/>
             <a:r>
-              <a:rPr sz="1200" b="0">
+              <a:rPr sz="1100" b="0">
                 <a:solidFill>
                   <a:srgbClr val="115511"/>
                 </a:solidFill>
               </a:rPr>
-              <a:t>✔  Oscillations cycliques reproduites après chaque injection</a:t>
-            </a:r>
-          </a:p>
-        </p:txBody>
-      </p:sp>
-      <p:sp>
-        <p:nvSpPr>
-          <p:cNvPr id="23" name="TextBox 22"/>
+              <a:t>✔  125 jours de cinétique validés</a:t>
+            </a:r>
+          </a:p>
+        </p:txBody>
+      </p:sp>
+      <p:sp>
+        <p:nvSpPr>
+          <p:cNvPr id="22" name="TextBox 21"/>
           <p:cNvSpPr txBox="1"/>
           <p:nvPr/>
         </p:nvSpPr>
         <p:spPr>
           <a:xfrm>
-            <a:off x="457200" y="5559552"/>
-            <a:ext cx="10972800" cy="256032"/>
+            <a:off x="365760" y="5303520"/>
+            <a:ext cx="5029200" cy="347472"/>
           </a:xfrm>
           <a:prstGeom prst="rect">
             <a:avLst/>
@@ -4791,84 +4748,40 @@
           <a:p>
             <a:pPr algn="l"/>
             <a:r>
-              <a:rPr sz="1200" b="0">
+              <a:rPr sz="1100" b="0">
                 <a:solidFill>
                   <a:srgbClr val="115511"/>
                 </a:solidFill>
               </a:rPr>
-              <a:t>✔  Cinétique sur 125 jours cohérente avec les données expérimentales</a:t>
-            </a:r>
-          </a:p>
-        </p:txBody>
-      </p:sp>
-      <p:sp>
-        <p:nvSpPr>
-          <p:cNvPr id="24" name="TextBox 23"/>
-          <p:cNvSpPr txBox="1"/>
-          <p:nvPr/>
-        </p:nvSpPr>
-        <p:spPr>
-          <a:xfrm>
-            <a:off x="457200" y="5815584"/>
-            <a:ext cx="10972800" cy="256032"/>
-          </a:xfrm>
-          <a:prstGeom prst="rect">
-            <a:avLst/>
-          </a:prstGeom>
-          <a:noFill/>
-        </p:spPr>
-        <p:txBody>
-          <a:bodyPr wrap="square">
-            <a:spAutoFit/>
-          </a:bodyPr>
-          <a:lstStyle/>
-          <a:p>
-            <a:pPr algn="l"/>
-            <a:r>
-              <a:rPr sz="1200" b="0">
-                <a:solidFill>
-                  <a:srgbClr val="115511"/>
-                </a:solidFill>
-              </a:rPr>
-              <a:t>✔  Modèle PK → Damage → Hématopoïèse validé sur rat</a:t>
-            </a:r>
-          </a:p>
-        </p:txBody>
-      </p:sp>
-      <p:sp>
-        <p:nvSpPr>
-          <p:cNvPr id="25" name="TextBox 24"/>
-          <p:cNvSpPr txBox="1"/>
-          <p:nvPr/>
-        </p:nvSpPr>
-        <p:spPr>
-          <a:xfrm>
-            <a:off x="457200" y="6071616"/>
-            <a:ext cx="10972800" cy="256032"/>
-          </a:xfrm>
-          <a:prstGeom prst="rect">
-            <a:avLst/>
-          </a:prstGeom>
-          <a:noFill/>
-        </p:spPr>
-        <p:txBody>
-          <a:bodyPr wrap="square">
-            <a:spAutoFit/>
-          </a:bodyPr>
-          <a:lstStyle/>
-          <a:p>
-            <a:pPr algn="l"/>
-            <a:r>
-              <a:rPr sz="1200" b="0">
-                <a:solidFill>
-                  <a:srgbClr val="00336B"/>
-                </a:solidFill>
-              </a:rPr>
-              <a:t>✔  Base solide pour le transfert rat → humain</a:t>
-            </a:r>
-          </a:p>
-        </p:txBody>
-      </p:sp>
+              <a:t>✔  PK → Damage → Hématopoïèse ✓</a:t>
+            </a:r>
+          </a:p>
+        </p:txBody>
+      </p:sp>
+      <p:pic>
+        <p:nvPicPr>
+          <p:cNvPr id="23" name="Picture 22" descr="Figure3_simulation.png"/>
+          <p:cNvPicPr>
+            <a:picLocks noChangeAspect="1"/>
+          </p:cNvPicPr>
+          <p:nvPr/>
+        </p:nvPicPr>
+        <p:blipFill>
+          <a:blip r:embed="rId2"/>
+          <a:stretch>
+            <a:fillRect/>
+          </a:stretch>
+        </p:blipFill>
+        <p:spPr>
+          <a:xfrm>
+            <a:off x="5394960" y="1261872"/>
+            <a:ext cx="6492240" cy="5230368"/>
+          </a:xfrm>
+          <a:prstGeom prst="rect">
+            <a:avLst/>
+          </a:prstGeom>
+        </p:spPr>
+      </p:pic>
     </p:spTree>
   </p:cSld>
   <p:clrMapOvr>
@@ -5092,7 +5005,7 @@
         <p:spPr>
           <a:xfrm>
             <a:off x="365760" y="1417320"/>
-            <a:ext cx="10972800" cy="365760"/>
+            <a:ext cx="11430000" cy="365760"/>
           </a:xfrm>
           <a:prstGeom prst="rect">
             <a:avLst/>
@@ -5107,32 +5020,56 @@
           <a:p>
             <a:pPr algn="l"/>
             <a:r>
-              <a:rPr sz="1400" b="1">
+              <a:rPr sz="1300" b="1">
                 <a:solidFill>
                   <a:srgbClr val="00336B"/>
                 </a:solidFill>
               </a:rPr>
-              <a:t>Démarche</a:t>
-            </a:r>
-          </a:p>
-        </p:txBody>
-      </p:sp>
-      <p:sp>
-        <p:nvSpPr>
-          <p:cNvPr id="8" name="Rectangle 7"/>
+              <a:t>Carboplatin AUC=5 — Q21D × 2  |  Nadirs neutrophiles &amp; plaquettes</a:t>
+            </a:r>
+          </a:p>
+        </p:txBody>
+      </p:sp>
+      <p:pic>
+        <p:nvPicPr>
+          <p:cNvPr id="8" name="Picture 7" descr="Figure4_Q21D_x2.png"/>
+          <p:cNvPicPr>
+            <a:picLocks noChangeAspect="1"/>
+          </p:cNvPicPr>
+          <p:nvPr/>
+        </p:nvPicPr>
+        <p:blipFill>
+          <a:blip r:embed="rId2"/>
+          <a:stretch>
+            <a:fillRect/>
+          </a:stretch>
+        </p:blipFill>
+        <p:spPr>
+          <a:xfrm>
+            <a:off x="365760" y="1828800"/>
+            <a:ext cx="11430000" cy="4160520"/>
+          </a:xfrm>
+          <a:prstGeom prst="rect">
+            <a:avLst/>
+          </a:prstGeom>
+        </p:spPr>
+      </p:pic>
+      <p:sp>
+        <p:nvSpPr>
+          <p:cNvPr id="9" name="Rectangle 8"/>
           <p:cNvSpPr/>
           <p:nvPr/>
         </p:nvSpPr>
         <p:spPr>
           <a:xfrm>
-            <a:off x="365760" y="1920240"/>
-            <a:ext cx="548640" cy="548640"/>
+            <a:off x="365760" y="6053328"/>
+            <a:ext cx="11430000" cy="411480"/>
           </a:xfrm>
           <a:prstGeom prst="rect">
             <a:avLst/>
           </a:prstGeom>
           <a:solidFill>
-            <a:srgbClr val="007AC2"/>
+            <a:srgbClr val="00336B"/>
           </a:solidFill>
           <a:ln>
             <a:noFill/>
@@ -5162,14 +5099,14 @@
       </p:sp>
       <p:sp>
         <p:nvSpPr>
-          <p:cNvPr id="9" name="TextBox 8"/>
+          <p:cNvPr id="10" name="TextBox 9"/>
           <p:cNvSpPr txBox="1"/>
           <p:nvPr/>
         </p:nvSpPr>
         <p:spPr>
           <a:xfrm>
-            <a:off x="365760" y="1920240"/>
-            <a:ext cx="548640" cy="548640"/>
+            <a:off x="640080" y="6108192"/>
+            <a:ext cx="10972800" cy="320040"/>
           </a:xfrm>
           <a:prstGeom prst="rect">
             <a:avLst/>
@@ -5184,632 +5121,9 @@
           <a:p>
             <a:pPr algn="ctr"/>
             <a:r>
-              <a:rPr sz="1600" b="1">
+              <a:rPr sz="1300" b="1">
                 <a:solidFill>
                   <a:srgbClr val="FFFFFF"/>
-                </a:solidFill>
-              </a:rPr>
-              <a:t>1</a:t>
-            </a:r>
-          </a:p>
-        </p:txBody>
-      </p:sp>
-      <p:sp>
-        <p:nvSpPr>
-          <p:cNvPr id="10" name="TextBox 9"/>
-          <p:cNvSpPr txBox="1"/>
-          <p:nvPr/>
-        </p:nvSpPr>
-        <p:spPr>
-          <a:xfrm>
-            <a:off x="1051560" y="1920240"/>
-            <a:ext cx="10058400" cy="320040"/>
-          </a:xfrm>
-          <a:prstGeom prst="rect">
-            <a:avLst/>
-          </a:prstGeom>
-          <a:noFill/>
-        </p:spPr>
-        <p:txBody>
-          <a:bodyPr wrap="square">
-            <a:spAutoFit/>
-          </a:bodyPr>
-          <a:lstStyle/>
-          <a:p>
-            <a:pPr algn="l"/>
-            <a:r>
-              <a:rPr sz="1300" b="1">
-                <a:solidFill>
-                  <a:srgbClr val="00336B"/>
-                </a:solidFill>
-              </a:rPr>
-              <a:t>Paramètres PK estimés sur rat</a:t>
-            </a:r>
-          </a:p>
-        </p:txBody>
-      </p:sp>
-      <p:sp>
-        <p:nvSpPr>
-          <p:cNvPr id="11" name="TextBox 10"/>
-          <p:cNvSpPr txBox="1"/>
-          <p:nvPr/>
-        </p:nvSpPr>
-        <p:spPr>
-          <a:xfrm>
-            <a:off x="1051560" y="2240280"/>
-            <a:ext cx="10058400" cy="320040"/>
-          </a:xfrm>
-          <a:prstGeom prst="rect">
-            <a:avLst/>
-          </a:prstGeom>
-          <a:noFill/>
-        </p:spPr>
-        <p:txBody>
-          <a:bodyPr wrap="square">
-            <a:spAutoFit/>
-          </a:bodyPr>
-          <a:lstStyle/>
-          <a:p>
-            <a:pPr algn="l"/>
-            <a:r>
-              <a:rPr sz="1100" b="0">
-                <a:solidFill>
-                  <a:srgbClr val="444444"/>
-                </a:solidFill>
-              </a:rPr>
-              <a:t>CL, V1, V2, Q transférés directement au modèle humain</a:t>
-            </a:r>
-          </a:p>
-        </p:txBody>
-      </p:sp>
-      <p:sp>
-        <p:nvSpPr>
-          <p:cNvPr id="12" name="Rectangle 11"/>
-          <p:cNvSpPr/>
-          <p:nvPr/>
-        </p:nvSpPr>
-        <p:spPr>
-          <a:xfrm>
-            <a:off x="365760" y="2926080"/>
-            <a:ext cx="548640" cy="548640"/>
-          </a:xfrm>
-          <a:prstGeom prst="rect">
-            <a:avLst/>
-          </a:prstGeom>
-          <a:solidFill>
-            <a:srgbClr val="007AC2"/>
-          </a:solidFill>
-          <a:ln>
-            <a:noFill/>
-          </a:ln>
-        </p:spPr>
-        <p:style>
-          <a:lnRef idx="1">
-            <a:schemeClr val="accent1"/>
-          </a:lnRef>
-          <a:fillRef idx="3">
-            <a:schemeClr val="accent1"/>
-          </a:fillRef>
-          <a:effectRef idx="2">
-            <a:schemeClr val="accent1"/>
-          </a:effectRef>
-          <a:fontRef idx="minor">
-            <a:schemeClr val="lt1"/>
-          </a:fontRef>
-        </p:style>
-        <p:txBody>
-          <a:bodyPr rtlCol="0" anchor="ctr"/>
-          <a:lstStyle/>
-          <a:p>
-            <a:pPr algn="ctr"/>
-          </a:p>
-        </p:txBody>
-      </p:sp>
-      <p:sp>
-        <p:nvSpPr>
-          <p:cNvPr id="13" name="TextBox 12"/>
-          <p:cNvSpPr txBox="1"/>
-          <p:nvPr/>
-        </p:nvSpPr>
-        <p:spPr>
-          <a:xfrm>
-            <a:off x="365760" y="2926080"/>
-            <a:ext cx="548640" cy="548640"/>
-          </a:xfrm>
-          <a:prstGeom prst="rect">
-            <a:avLst/>
-          </a:prstGeom>
-          <a:noFill/>
-        </p:spPr>
-        <p:txBody>
-          <a:bodyPr wrap="square">
-            <a:spAutoFit/>
-          </a:bodyPr>
-          <a:lstStyle/>
-          <a:p>
-            <a:pPr algn="ctr"/>
-            <a:r>
-              <a:rPr sz="1600" b="1">
-                <a:solidFill>
-                  <a:srgbClr val="FFFFFF"/>
-                </a:solidFill>
-              </a:rPr>
-              <a:t>2</a:t>
-            </a:r>
-          </a:p>
-        </p:txBody>
-      </p:sp>
-      <p:sp>
-        <p:nvSpPr>
-          <p:cNvPr id="14" name="TextBox 13"/>
-          <p:cNvSpPr txBox="1"/>
-          <p:nvPr/>
-        </p:nvSpPr>
-        <p:spPr>
-          <a:xfrm>
-            <a:off x="1051560" y="2926080"/>
-            <a:ext cx="10058400" cy="320040"/>
-          </a:xfrm>
-          <a:prstGeom prst="rect">
-            <a:avLst/>
-          </a:prstGeom>
-          <a:noFill/>
-        </p:spPr>
-        <p:txBody>
-          <a:bodyPr wrap="square">
-            <a:spAutoFit/>
-          </a:bodyPr>
-          <a:lstStyle/>
-          <a:p>
-            <a:pPr algn="l"/>
-            <a:r>
-              <a:rPr sz="1300" b="1">
-                <a:solidFill>
-                  <a:srgbClr val="00336B"/>
-                </a:solidFill>
-              </a:rPr>
-              <a:t>Simulation humaine</a:t>
-            </a:r>
-          </a:p>
-        </p:txBody>
-      </p:sp>
-      <p:sp>
-        <p:nvSpPr>
-          <p:cNvPr id="15" name="TextBox 14"/>
-          <p:cNvSpPr txBox="1"/>
-          <p:nvPr/>
-        </p:nvSpPr>
-        <p:spPr>
-          <a:xfrm>
-            <a:off x="1051560" y="3246120"/>
-            <a:ext cx="10058400" cy="320040"/>
-          </a:xfrm>
-          <a:prstGeom prst="rect">
-            <a:avLst/>
-          </a:prstGeom>
-          <a:noFill/>
-        </p:spPr>
-        <p:txBody>
-          <a:bodyPr wrap="square">
-            <a:spAutoFit/>
-          </a:bodyPr>
-          <a:lstStyle/>
-          <a:p>
-            <a:pPr algn="l"/>
-            <a:r>
-              <a:rPr sz="1100" b="0">
-                <a:solidFill>
-                  <a:srgbClr val="444444"/>
-                </a:solidFill>
-              </a:rPr>
-              <a:t>Carboplatin AUC=5 (750 mg pour GFR=125) — 2 cycles Q21D</a:t>
-            </a:r>
-          </a:p>
-        </p:txBody>
-      </p:sp>
-      <p:sp>
-        <p:nvSpPr>
-          <p:cNvPr id="16" name="Rectangle 15"/>
-          <p:cNvSpPr/>
-          <p:nvPr/>
-        </p:nvSpPr>
-        <p:spPr>
-          <a:xfrm>
-            <a:off x="365760" y="3931920"/>
-            <a:ext cx="548640" cy="548640"/>
-          </a:xfrm>
-          <a:prstGeom prst="rect">
-            <a:avLst/>
-          </a:prstGeom>
-          <a:solidFill>
-            <a:srgbClr val="218B4E"/>
-          </a:solidFill>
-          <a:ln>
-            <a:noFill/>
-          </a:ln>
-        </p:spPr>
-        <p:style>
-          <a:lnRef idx="1">
-            <a:schemeClr val="accent1"/>
-          </a:lnRef>
-          <a:fillRef idx="3">
-            <a:schemeClr val="accent1"/>
-          </a:fillRef>
-          <a:effectRef idx="2">
-            <a:schemeClr val="accent1"/>
-          </a:effectRef>
-          <a:fontRef idx="minor">
-            <a:schemeClr val="lt1"/>
-          </a:fontRef>
-        </p:style>
-        <p:txBody>
-          <a:bodyPr rtlCol="0" anchor="ctr"/>
-          <a:lstStyle/>
-          <a:p>
-            <a:pPr algn="ctr"/>
-          </a:p>
-        </p:txBody>
-      </p:sp>
-      <p:sp>
-        <p:nvSpPr>
-          <p:cNvPr id="17" name="TextBox 16"/>
-          <p:cNvSpPr txBox="1"/>
-          <p:nvPr/>
-        </p:nvSpPr>
-        <p:spPr>
-          <a:xfrm>
-            <a:off x="365760" y="3931920"/>
-            <a:ext cx="548640" cy="548640"/>
-          </a:xfrm>
-          <a:prstGeom prst="rect">
-            <a:avLst/>
-          </a:prstGeom>
-          <a:noFill/>
-        </p:spPr>
-        <p:txBody>
-          <a:bodyPr wrap="square">
-            <a:spAutoFit/>
-          </a:bodyPr>
-          <a:lstStyle/>
-          <a:p>
-            <a:pPr algn="ctr"/>
-            <a:r>
-              <a:rPr sz="1600" b="1">
-                <a:solidFill>
-                  <a:srgbClr val="FFFFFF"/>
-                </a:solidFill>
-              </a:rPr>
-              <a:t>3</a:t>
-            </a:r>
-          </a:p>
-        </p:txBody>
-      </p:sp>
-      <p:sp>
-        <p:nvSpPr>
-          <p:cNvPr id="18" name="TextBox 17"/>
-          <p:cNvSpPr txBox="1"/>
-          <p:nvPr/>
-        </p:nvSpPr>
-        <p:spPr>
-          <a:xfrm>
-            <a:off x="1051560" y="3931920"/>
-            <a:ext cx="10058400" cy="320040"/>
-          </a:xfrm>
-          <a:prstGeom prst="rect">
-            <a:avLst/>
-          </a:prstGeom>
-          <a:noFill/>
-        </p:spPr>
-        <p:txBody>
-          <a:bodyPr wrap="square">
-            <a:spAutoFit/>
-          </a:bodyPr>
-          <a:lstStyle/>
-          <a:p>
-            <a:pPr algn="l"/>
-            <a:r>
-              <a:rPr sz="1300" b="1">
-                <a:solidFill>
-                  <a:srgbClr val="00336B"/>
-                </a:solidFill>
-              </a:rPr>
-              <a:t>Comparaison données cliniques</a:t>
-            </a:r>
-          </a:p>
-        </p:txBody>
-      </p:sp>
-      <p:sp>
-        <p:nvSpPr>
-          <p:cNvPr id="19" name="TextBox 18"/>
-          <p:cNvSpPr txBox="1"/>
-          <p:nvPr/>
-        </p:nvSpPr>
-        <p:spPr>
-          <a:xfrm>
-            <a:off x="1051560" y="4251960"/>
-            <a:ext cx="10058400" cy="320040"/>
-          </a:xfrm>
-          <a:prstGeom prst="rect">
-            <a:avLst/>
-          </a:prstGeom>
-          <a:noFill/>
-        </p:spPr>
-        <p:txBody>
-          <a:bodyPr wrap="square">
-            <a:spAutoFit/>
-          </a:bodyPr>
-          <a:lstStyle/>
-          <a:p>
-            <a:pPr algn="l"/>
-            <a:r>
-              <a:rPr sz="1100" b="0">
-                <a:solidFill>
-                  <a:srgbClr val="444444"/>
-                </a:solidFill>
-              </a:rPr>
-              <a:t>Courbes modèle superposées aux observations (neutrophiles + plaquettes)</a:t>
-            </a:r>
-          </a:p>
-        </p:txBody>
-      </p:sp>
-      <p:sp>
-        <p:nvSpPr>
-          <p:cNvPr id="20" name="Rectangle 19"/>
-          <p:cNvSpPr/>
-          <p:nvPr/>
-        </p:nvSpPr>
-        <p:spPr>
-          <a:xfrm>
-            <a:off x="365760" y="4937760"/>
-            <a:ext cx="548640" cy="548640"/>
-          </a:xfrm>
-          <a:prstGeom prst="rect">
-            <a:avLst/>
-          </a:prstGeom>
-          <a:solidFill>
-            <a:srgbClr val="218B4E"/>
-          </a:solidFill>
-          <a:ln>
-            <a:noFill/>
-          </a:ln>
-        </p:spPr>
-        <p:style>
-          <a:lnRef idx="1">
-            <a:schemeClr val="accent1"/>
-          </a:lnRef>
-          <a:fillRef idx="3">
-            <a:schemeClr val="accent1"/>
-          </a:fillRef>
-          <a:effectRef idx="2">
-            <a:schemeClr val="accent1"/>
-          </a:effectRef>
-          <a:fontRef idx="minor">
-            <a:schemeClr val="lt1"/>
-          </a:fontRef>
-        </p:style>
-        <p:txBody>
-          <a:bodyPr rtlCol="0" anchor="ctr"/>
-          <a:lstStyle/>
-          <a:p>
-            <a:pPr algn="ctr"/>
-          </a:p>
-        </p:txBody>
-      </p:sp>
-      <p:sp>
-        <p:nvSpPr>
-          <p:cNvPr id="21" name="TextBox 20"/>
-          <p:cNvSpPr txBox="1"/>
-          <p:nvPr/>
-        </p:nvSpPr>
-        <p:spPr>
-          <a:xfrm>
-            <a:off x="365760" y="4937760"/>
-            <a:ext cx="548640" cy="548640"/>
-          </a:xfrm>
-          <a:prstGeom prst="rect">
-            <a:avLst/>
-          </a:prstGeom>
-          <a:noFill/>
-        </p:spPr>
-        <p:txBody>
-          <a:bodyPr wrap="square">
-            <a:spAutoFit/>
-          </a:bodyPr>
-          <a:lstStyle/>
-          <a:p>
-            <a:pPr algn="ctr"/>
-            <a:r>
-              <a:rPr sz="1600" b="1">
-                <a:solidFill>
-                  <a:srgbClr val="FFFFFF"/>
-                </a:solidFill>
-              </a:rPr>
-              <a:t>4</a:t>
-            </a:r>
-          </a:p>
-        </p:txBody>
-      </p:sp>
-      <p:sp>
-        <p:nvSpPr>
-          <p:cNvPr id="22" name="TextBox 21"/>
-          <p:cNvSpPr txBox="1"/>
-          <p:nvPr/>
-        </p:nvSpPr>
-        <p:spPr>
-          <a:xfrm>
-            <a:off x="1051560" y="4937760"/>
-            <a:ext cx="10058400" cy="320040"/>
-          </a:xfrm>
-          <a:prstGeom prst="rect">
-            <a:avLst/>
-          </a:prstGeom>
-          <a:noFill/>
-        </p:spPr>
-        <p:txBody>
-          <a:bodyPr wrap="square">
-            <a:spAutoFit/>
-          </a:bodyPr>
-          <a:lstStyle/>
-          <a:p>
-            <a:pPr algn="l"/>
-            <a:r>
-              <a:rPr sz="1300" b="1">
-                <a:solidFill>
-                  <a:srgbClr val="00336B"/>
-                </a:solidFill>
-              </a:rPr>
-              <a:t>Validation</a:t>
-            </a:r>
-          </a:p>
-        </p:txBody>
-      </p:sp>
-      <p:sp>
-        <p:nvSpPr>
-          <p:cNvPr id="23" name="TextBox 22"/>
-          <p:cNvSpPr txBox="1"/>
-          <p:nvPr/>
-        </p:nvSpPr>
-        <p:spPr>
-          <a:xfrm>
-            <a:off x="1051560" y="5257800"/>
-            <a:ext cx="10058400" cy="320040"/>
-          </a:xfrm>
-          <a:prstGeom prst="rect">
-            <a:avLst/>
-          </a:prstGeom>
-          <a:noFill/>
-        </p:spPr>
-        <p:txBody>
-          <a:bodyPr wrap="square">
-            <a:spAutoFit/>
-          </a:bodyPr>
-          <a:lstStyle/>
-          <a:p>
-            <a:pPr algn="l"/>
-            <a:r>
-              <a:rPr sz="1100" b="0">
-                <a:solidFill>
-                  <a:srgbClr val="444444"/>
-                </a:solidFill>
-              </a:rPr>
-              <a:t>Nadirs bien reproduits — variabilité inter-patient identifiée</a:t>
-            </a:r>
-          </a:p>
-        </p:txBody>
-      </p:sp>
-      <p:sp>
-        <p:nvSpPr>
-          <p:cNvPr id="24" name="Rectangle 23"/>
-          <p:cNvSpPr/>
-          <p:nvPr/>
-        </p:nvSpPr>
-        <p:spPr>
-          <a:xfrm>
-            <a:off x="365760" y="5806440"/>
-            <a:ext cx="11430000" cy="640080"/>
-          </a:xfrm>
-          <a:prstGeom prst="rect">
-            <a:avLst/>
-          </a:prstGeom>
-          <a:solidFill>
-            <a:srgbClr val="F2F2F2"/>
-          </a:solidFill>
-          <a:ln>
-            <a:noFill/>
-          </a:ln>
-        </p:spPr>
-        <p:style>
-          <a:lnRef idx="1">
-            <a:schemeClr val="accent1"/>
-          </a:lnRef>
-          <a:fillRef idx="3">
-            <a:schemeClr val="accent1"/>
-          </a:fillRef>
-          <a:effectRef idx="2">
-            <a:schemeClr val="accent1"/>
-          </a:effectRef>
-          <a:fontRef idx="minor">
-            <a:schemeClr val="lt1"/>
-          </a:fontRef>
-        </p:style>
-        <p:txBody>
-          <a:bodyPr rtlCol="0" anchor="ctr"/>
-          <a:lstStyle/>
-          <a:p>
-            <a:pPr algn="ctr"/>
-          </a:p>
-        </p:txBody>
-      </p:sp>
-      <p:sp>
-        <p:nvSpPr>
-          <p:cNvPr id="25" name="Rectangle 24"/>
-          <p:cNvSpPr/>
-          <p:nvPr/>
-        </p:nvSpPr>
-        <p:spPr>
-          <a:xfrm>
-            <a:off x="365760" y="5806440"/>
-            <a:ext cx="137160" cy="640080"/>
-          </a:xfrm>
-          <a:prstGeom prst="rect">
-            <a:avLst/>
-          </a:prstGeom>
-          <a:solidFill>
-            <a:srgbClr val="218B4E"/>
-          </a:solidFill>
-          <a:ln>
-            <a:noFill/>
-          </a:ln>
-        </p:spPr>
-        <p:style>
-          <a:lnRef idx="1">
-            <a:schemeClr val="accent1"/>
-          </a:lnRef>
-          <a:fillRef idx="3">
-            <a:schemeClr val="accent1"/>
-          </a:fillRef>
-          <a:effectRef idx="2">
-            <a:schemeClr val="accent1"/>
-          </a:effectRef>
-          <a:fontRef idx="minor">
-            <a:schemeClr val="lt1"/>
-          </a:fontRef>
-        </p:style>
-        <p:txBody>
-          <a:bodyPr rtlCol="0" anchor="ctr"/>
-          <a:lstStyle/>
-          <a:p>
-            <a:pPr algn="ctr"/>
-          </a:p>
-        </p:txBody>
-      </p:sp>
-      <p:sp>
-        <p:nvSpPr>
-          <p:cNvPr id="26" name="TextBox 25"/>
-          <p:cNvSpPr txBox="1"/>
-          <p:nvPr/>
-        </p:nvSpPr>
-        <p:spPr>
-          <a:xfrm>
-            <a:off x="640080" y="5897880"/>
-            <a:ext cx="10972800" cy="411480"/>
-          </a:xfrm>
-          <a:prstGeom prst="rect">
-            <a:avLst/>
-          </a:prstGeom>
-          <a:noFill/>
-        </p:spPr>
-        <p:txBody>
-          <a:bodyPr wrap="square">
-            <a:spAutoFit/>
-          </a:bodyPr>
-          <a:lstStyle/>
-          <a:p>
-            <a:pPr algn="ctr"/>
-            <a:r>
-              <a:rPr sz="1400" b="1">
-                <a:solidFill>
-                  <a:srgbClr val="00336B"/>
                 </a:solidFill>
               </a:rPr>
               <a:t>Chaîne complète validée :  Souris  →  Rat  →  Humain  ✔</a:t>
@@ -6065,16 +5379,40 @@
           </a:p>
         </p:txBody>
       </p:sp>
-      <p:sp>
-        <p:nvSpPr>
-          <p:cNvPr id="8" name="TextBox 7"/>
+      <p:pic>
+        <p:nvPicPr>
+          <p:cNvPr id="8" name="Picture 7" descr="Figure4_VPC_AUC5.png"/>
+          <p:cNvPicPr>
+            <a:picLocks noChangeAspect="1"/>
+          </p:cNvPicPr>
+          <p:nvPr/>
+        </p:nvPicPr>
+        <p:blipFill>
+          <a:blip r:embed="rId2"/>
+          <a:stretch>
+            <a:fillRect/>
+          </a:stretch>
+        </p:blipFill>
+        <p:spPr>
+          <a:xfrm>
+            <a:off x="274320" y="1298448"/>
+            <a:ext cx="3840480" cy="5166360"/>
+          </a:xfrm>
+          <a:prstGeom prst="rect">
+            <a:avLst/>
+          </a:prstGeom>
+        </p:spPr>
+      </p:pic>
+      <p:sp>
+        <p:nvSpPr>
+          <p:cNvPr id="9" name="TextBox 8"/>
           <p:cNvSpPr txBox="1"/>
           <p:nvPr/>
         </p:nvSpPr>
         <p:spPr>
           <a:xfrm>
-            <a:off x="548640" y="1920240"/>
-            <a:ext cx="10972800" cy="457200"/>
+            <a:off x="4389120" y="1463040"/>
+            <a:ext cx="7498079" cy="365760"/>
           </a:xfrm>
           <a:prstGeom prst="rect">
             <a:avLst/>
@@ -6089,26 +5427,26 @@
           <a:p>
             <a:pPr algn="l"/>
             <a:r>
-              <a:rPr sz="1300" b="0">
+              <a:rPr sz="1200" b="1">
                 <a:solidFill>
                   <a:srgbClr val="00336B"/>
                 </a:solidFill>
               </a:rPr>
-              <a:t>▸  1000 patients simulés (Supp. S11, GFR=125 fixe)</a:t>
-            </a:r>
-          </a:p>
-        </p:txBody>
-      </p:sp>
-      <p:sp>
-        <p:nvSpPr>
-          <p:cNvPr id="9" name="TextBox 8"/>
+              <a:t>1000 patients simulés (GFR=125 fixe)</a:t>
+            </a:r>
+          </a:p>
+        </p:txBody>
+      </p:sp>
+      <p:sp>
+        <p:nvSpPr>
+          <p:cNvPr id="10" name="TextBox 9"/>
           <p:cNvSpPr txBox="1"/>
           <p:nvPr/>
         </p:nvSpPr>
         <p:spPr>
           <a:xfrm>
-            <a:off x="548640" y="2468880"/>
-            <a:ext cx="10972800" cy="457200"/>
+            <a:off x="4389120" y="1920240"/>
+            <a:ext cx="7498079" cy="347472"/>
           </a:xfrm>
           <a:prstGeom prst="rect">
             <a:avLst/>
@@ -6123,26 +5461,26 @@
           <a:p>
             <a:pPr algn="l"/>
             <a:r>
-              <a:rPr sz="1300" b="0">
+              <a:rPr sz="1100" b="0">
                 <a:solidFill>
                   <a:srgbClr val="00336B"/>
                 </a:solidFill>
               </a:rPr>
-              <a:t>▸  Intervalles de prédiction 5–95% calculés pour neutrophiles et plaquettes</a:t>
-            </a:r>
-          </a:p>
-        </p:txBody>
-      </p:sp>
-      <p:sp>
-        <p:nvSpPr>
-          <p:cNvPr id="10" name="TextBox 9"/>
+              <a:t>▸  Intervalles de prédiction 5–95%</a:t>
+            </a:r>
+          </a:p>
+        </p:txBody>
+      </p:sp>
+      <p:sp>
+        <p:nvSpPr>
+          <p:cNvPr id="11" name="TextBox 10"/>
           <p:cNvSpPr txBox="1"/>
           <p:nvPr/>
         </p:nvSpPr>
         <p:spPr>
           <a:xfrm>
-            <a:off x="548640" y="3017520"/>
-            <a:ext cx="10972800" cy="457200"/>
+            <a:off x="4389120" y="2304288"/>
+            <a:ext cx="7498079" cy="347472"/>
           </a:xfrm>
           <a:prstGeom prst="rect">
             <a:avLst/>
@@ -6157,26 +5495,26 @@
           <a:p>
             <a:pPr algn="l"/>
             <a:r>
-              <a:rPr sz="1300" b="0">
+              <a:rPr sz="1100" b="0">
                 <a:solidFill>
                   <a:srgbClr val="00336B"/>
                 </a:solidFill>
               </a:rPr>
-              <a:t>▸  Erreur résiduelle intégrée dans la simulation populationnelle</a:t>
-            </a:r>
-          </a:p>
-        </p:txBody>
-      </p:sp>
-      <p:sp>
-        <p:nvSpPr>
-          <p:cNvPr id="11" name="TextBox 10"/>
+              <a:t>▸  Erreur résiduelle intégrée</a:t>
+            </a:r>
+          </a:p>
+        </p:txBody>
+      </p:sp>
+      <p:sp>
+        <p:nvSpPr>
+          <p:cNvPr id="12" name="TextBox 11"/>
           <p:cNvSpPr txBox="1"/>
           <p:nvPr/>
         </p:nvSpPr>
         <p:spPr>
           <a:xfrm>
-            <a:off x="548640" y="3566160"/>
-            <a:ext cx="10972800" cy="457200"/>
+            <a:off x="4389120" y="2688336"/>
+            <a:ext cx="7498079" cy="347472"/>
           </a:xfrm>
           <a:prstGeom prst="rect">
             <a:avLst/>
@@ -6191,26 +5529,26 @@
           <a:p>
             <a:pPr algn="l"/>
             <a:r>
-              <a:rPr sz="1300" b="0">
+              <a:rPr sz="1100" b="0">
                 <a:solidFill>
                   <a:srgbClr val="00336B"/>
                 </a:solidFill>
               </a:rPr>
-              <a:t>▸  Nadirs cycliques bien capturés par les intervalles de prédiction</a:t>
-            </a:r>
-          </a:p>
-        </p:txBody>
-      </p:sp>
-      <p:sp>
-        <p:nvSpPr>
-          <p:cNvPr id="12" name="Rectangle 11"/>
+              <a:t>▸  Nadirs cycliques bien capturés</a:t>
+            </a:r>
+          </a:p>
+        </p:txBody>
+      </p:sp>
+      <p:sp>
+        <p:nvSpPr>
+          <p:cNvPr id="13" name="Rectangle 12"/>
           <p:cNvSpPr/>
           <p:nvPr/>
         </p:nvSpPr>
         <p:spPr>
           <a:xfrm>
-            <a:off x="365760" y="4297680"/>
-            <a:ext cx="11430000" cy="36576"/>
+            <a:off x="4389120" y="3200400"/>
+            <a:ext cx="7498079" cy="36576"/>
           </a:xfrm>
           <a:prstGeom prst="rect">
             <a:avLst/>
@@ -6246,14 +5584,14 @@
       </p:sp>
       <p:sp>
         <p:nvSpPr>
-          <p:cNvPr id="13" name="TextBox 12"/>
+          <p:cNvPr id="14" name="TextBox 13"/>
           <p:cNvSpPr txBox="1"/>
           <p:nvPr/>
         </p:nvSpPr>
         <p:spPr>
           <a:xfrm>
-            <a:off x="365760" y="4434840"/>
-            <a:ext cx="10972800" cy="365760"/>
+            <a:off x="4389120" y="3291840"/>
+            <a:ext cx="7498079" cy="347472"/>
           </a:xfrm>
           <a:prstGeom prst="rect">
             <a:avLst/>
@@ -6268,238 +5606,40 @@
           <a:p>
             <a:pPr algn="l"/>
             <a:r>
-              <a:rPr sz="1400" b="1">
+              <a:rPr sz="1200" b="1">
                 <a:solidFill>
                   <a:srgbClr val="00336B"/>
                 </a:solidFill>
               </a:rPr>
-              <a:t>Grades NCI-CTCAE — Figure 4c</a:t>
-            </a:r>
-          </a:p>
-        </p:txBody>
-      </p:sp>
-      <p:sp>
-        <p:nvSpPr>
-          <p:cNvPr id="14" name="Rectangle 13"/>
-          <p:cNvSpPr/>
-          <p:nvPr/>
-        </p:nvSpPr>
-        <p:spPr>
-          <a:xfrm>
-            <a:off x="365760" y="4892040"/>
-            <a:ext cx="5303520" cy="457200"/>
-          </a:xfrm>
-          <a:prstGeom prst="rect">
-            <a:avLst/>
-          </a:prstGeom>
-          <a:solidFill>
-            <a:srgbClr val="218B4E"/>
-          </a:solidFill>
-          <a:ln>
-            <a:noFill/>
-          </a:ln>
-        </p:spPr>
-        <p:style>
-          <a:lnRef idx="1">
-            <a:schemeClr val="accent1"/>
-          </a:lnRef>
-          <a:fillRef idx="3">
-            <a:schemeClr val="accent1"/>
-          </a:fillRef>
-          <a:effectRef idx="2">
-            <a:schemeClr val="accent1"/>
-          </a:effectRef>
-          <a:fontRef idx="minor">
-            <a:schemeClr val="lt1"/>
-          </a:fontRef>
-        </p:style>
-        <p:txBody>
-          <a:bodyPr rtlCol="0" anchor="ctr"/>
-          <a:lstStyle/>
-          <a:p>
-            <a:pPr algn="ctr"/>
-          </a:p>
-        </p:txBody>
-      </p:sp>
-      <p:sp>
-        <p:nvSpPr>
-          <p:cNvPr id="15" name="TextBox 14"/>
-          <p:cNvSpPr txBox="1"/>
-          <p:nvPr/>
-        </p:nvSpPr>
-        <p:spPr>
-          <a:xfrm>
-            <a:off x="502920" y="4919472"/>
-            <a:ext cx="5029200" cy="384048"/>
-          </a:xfrm>
-          <a:prstGeom prst="rect">
-            <a:avLst/>
-          </a:prstGeom>
-          <a:noFill/>
-        </p:spPr>
-        <p:txBody>
-          <a:bodyPr wrap="square">
-            <a:spAutoFit/>
-          </a:bodyPr>
-          <a:lstStyle/>
-          <a:p>
-            <a:pPr algn="l"/>
-            <a:r>
-              <a:rPr sz="1300" b="1">
-                <a:solidFill>
-                  <a:srgbClr val="FFFFFF"/>
-                </a:solidFill>
-              </a:rPr>
-              <a:t>Neutrophiles</a:t>
-            </a:r>
-          </a:p>
-        </p:txBody>
-      </p:sp>
-      <p:sp>
-        <p:nvSpPr>
-          <p:cNvPr id="16" name="TextBox 15"/>
-          <p:cNvSpPr txBox="1"/>
-          <p:nvPr/>
-        </p:nvSpPr>
-        <p:spPr>
-          <a:xfrm>
-            <a:off x="502920" y="5440680"/>
-            <a:ext cx="5029200" cy="365760"/>
-          </a:xfrm>
-          <a:prstGeom prst="rect">
-            <a:avLst/>
-          </a:prstGeom>
-          <a:noFill/>
-        </p:spPr>
-        <p:txBody>
-          <a:bodyPr wrap="square">
-            <a:spAutoFit/>
-          </a:bodyPr>
-          <a:lstStyle/>
-          <a:p>
-            <a:pPr algn="l"/>
-            <a:r>
-              <a:rPr sz="1200" b="0">
-                <a:solidFill>
-                  <a:srgbClr val="00336B"/>
-                </a:solidFill>
-              </a:rPr>
-              <a:t>Nadir = 2.30 × 10⁹/L  →  Grade 0</a:t>
-            </a:r>
-          </a:p>
-        </p:txBody>
-      </p:sp>
-      <p:sp>
-        <p:nvSpPr>
-          <p:cNvPr id="17" name="Rectangle 16"/>
-          <p:cNvSpPr/>
-          <p:nvPr/>
-        </p:nvSpPr>
-        <p:spPr>
-          <a:xfrm>
-            <a:off x="6035040" y="4892040"/>
-            <a:ext cx="5303520" cy="457200"/>
-          </a:xfrm>
-          <a:prstGeom prst="rect">
-            <a:avLst/>
-          </a:prstGeom>
-          <a:solidFill>
-            <a:srgbClr val="218B4E"/>
-          </a:solidFill>
-          <a:ln>
-            <a:noFill/>
-          </a:ln>
-        </p:spPr>
-        <p:style>
-          <a:lnRef idx="1">
-            <a:schemeClr val="accent1"/>
-          </a:lnRef>
-          <a:fillRef idx="3">
-            <a:schemeClr val="accent1"/>
-          </a:fillRef>
-          <a:effectRef idx="2">
-            <a:schemeClr val="accent1"/>
-          </a:effectRef>
-          <a:fontRef idx="minor">
-            <a:schemeClr val="lt1"/>
-          </a:fontRef>
-        </p:style>
-        <p:txBody>
-          <a:bodyPr rtlCol="0" anchor="ctr"/>
-          <a:lstStyle/>
-          <a:p>
-            <a:pPr algn="ctr"/>
-          </a:p>
-        </p:txBody>
-      </p:sp>
-      <p:sp>
-        <p:nvSpPr>
-          <p:cNvPr id="18" name="TextBox 17"/>
-          <p:cNvSpPr txBox="1"/>
-          <p:nvPr/>
-        </p:nvSpPr>
-        <p:spPr>
-          <a:xfrm>
-            <a:off x="6172200" y="4919472"/>
-            <a:ext cx="5029200" cy="384048"/>
-          </a:xfrm>
-          <a:prstGeom prst="rect">
-            <a:avLst/>
-          </a:prstGeom>
-          <a:noFill/>
-        </p:spPr>
-        <p:txBody>
-          <a:bodyPr wrap="square">
-            <a:spAutoFit/>
-          </a:bodyPr>
-          <a:lstStyle/>
-          <a:p>
-            <a:pPr algn="l"/>
-            <a:r>
-              <a:rPr sz="1300" b="1">
-                <a:solidFill>
-                  <a:srgbClr val="FFFFFF"/>
-                </a:solidFill>
-              </a:rPr>
-              <a:t>Plaquettes</a:t>
-            </a:r>
-          </a:p>
-        </p:txBody>
-      </p:sp>
-      <p:sp>
-        <p:nvSpPr>
-          <p:cNvPr id="19" name="TextBox 18"/>
-          <p:cNvSpPr txBox="1"/>
-          <p:nvPr/>
-        </p:nvSpPr>
-        <p:spPr>
-          <a:xfrm>
-            <a:off x="6172200" y="5440680"/>
-            <a:ext cx="5029200" cy="365760"/>
-          </a:xfrm>
-          <a:prstGeom prst="rect">
-            <a:avLst/>
-          </a:prstGeom>
-          <a:noFill/>
-        </p:spPr>
-        <p:txBody>
-          <a:bodyPr wrap="square">
-            <a:spAutoFit/>
-          </a:bodyPr>
-          <a:lstStyle/>
-          <a:p>
-            <a:pPr algn="l"/>
-            <a:r>
-              <a:rPr sz="1200" b="0">
-                <a:solidFill>
-                  <a:srgbClr val="00336B"/>
-                </a:solidFill>
-              </a:rPr>
-              <a:t>Nadir = 190 × 10⁹/L   →  Grade 0</a:t>
-            </a:r>
-          </a:p>
-        </p:txBody>
-      </p:sp>
+              <a:t>Grades NCI-CTCAE (Figure 4c)</a:t>
+            </a:r>
+          </a:p>
+        </p:txBody>
+      </p:sp>
+      <p:pic>
+        <p:nvPicPr>
+          <p:cNvPr id="15" name="Picture 14" descr="Figure4c_grades_AUC5.png"/>
+          <p:cNvPicPr>
+            <a:picLocks noChangeAspect="1"/>
+          </p:cNvPicPr>
+          <p:nvPr/>
+        </p:nvPicPr>
+        <p:blipFill>
+          <a:blip r:embed="rId3"/>
+          <a:stretch>
+            <a:fillRect/>
+          </a:stretch>
+        </p:blipFill>
+        <p:spPr>
+          <a:xfrm>
+            <a:off x="4389120" y="3749039"/>
+            <a:ext cx="7498079" cy="2514600"/>
+          </a:xfrm>
+          <a:prstGeom prst="rect">
+            <a:avLst/>
+          </a:prstGeom>
+        </p:spPr>
+      </p:pic>
     </p:spTree>
   </p:cSld>
   <p:clrMapOvr>

</xml_diff>

<commit_message>
Fix image compatibility: switch PNG to JPEG in PPTX
PNG embedded via python-pptx causes rendering issues in Office Online
and some viewers. JPEG ensures universal compatibility.

https://claude.ai/code/session_01GxFodoNdE8EwfQNaex4rq6
</commit_message>
<xml_diff>
--- a/reunion_point/reunion_prochaine.pptx
+++ b/reunion_point/reunion_prochaine.pptx
@@ -4760,7 +4760,7 @@
       </p:sp>
       <p:pic>
         <p:nvPicPr>
-          <p:cNvPr id="23" name="Picture 22" descr="Figure3_simulation.png"/>
+          <p:cNvPr id="23" name="Picture 22" descr="Figure3_simulation.jpg"/>
           <p:cNvPicPr>
             <a:picLocks noChangeAspect="1"/>
           </p:cNvPicPr>
@@ -5032,7 +5032,7 @@
       </p:sp>
       <p:pic>
         <p:nvPicPr>
-          <p:cNvPr id="8" name="Picture 7" descr="Figure4_Q21D_x2.png"/>
+          <p:cNvPr id="8" name="Picture 7" descr="Figure4_Q21D_x2.jpg"/>
           <p:cNvPicPr>
             <a:picLocks noChangeAspect="1"/>
           </p:cNvPicPr>
@@ -5381,7 +5381,7 @@
       </p:sp>
       <p:pic>
         <p:nvPicPr>
-          <p:cNvPr id="8" name="Picture 7" descr="Figure4_VPC_AUC5.png"/>
+          <p:cNvPr id="8" name="Picture 7" descr="Figure4_VPC_AUC5.jpg"/>
           <p:cNvPicPr>
             <a:picLocks noChangeAspect="1"/>
           </p:cNvPicPr>
@@ -5618,7 +5618,7 @@
       </p:sp>
       <p:pic>
         <p:nvPicPr>
-          <p:cNvPr id="15" name="Picture 14" descr="Figure4c_grades_AUC5.png"/>
+          <p:cNvPr id="15" name="Picture 14" descr="Figure4c_grades_AUC5.jpg"/>
           <p:cNvPicPr>
             <a:picLocks noChangeAspect="1"/>
           </p:cNvPicPr>

</xml_diff>

<commit_message>
Add slide: adaptation du modèle Fornari pour ADC (ce qu'on garde / remplace)
- Nouvelle slide dans reunion_prochaine.pptx (slide 8)
- Colonne verte : ODEs, baselines, MTT, feedbacks γ, grades NCI-CTCAE
- Colonne rouge : PK → Cavg fixe, Damage → Emax, Slope à recalibrer
- Note : Slope/Emax à estimer par analyse de sensibilité
- Ajout du script add_fornari_slide.py

https://claude.ai/code/session_019UX7gxMosZJG12nhJXPH26
</commit_message>
<xml_diff>
--- a/reunion_point/reunion_prochaine.pptx
+++ b/reunion_point/reunion_prochaine.pptx
@@ -12,6 +12,7 @@
     <p:sldId id="260" r:id="rId11"/>
     <p:sldId id="261" r:id="rId12"/>
     <p:sldId id="262" r:id="rId13"/>
+    <p:sldId id="263" r:id="rId14"/>
   </p:sldIdLst>
   <p:sldSz cx="12188952" cy="6858000" type="screen4x3"/>
   <p:notesSz cx="6858000" cy="9144000"/>
@@ -6681,6 +6682,590 @@
                 </a:solidFill>
               </a:rPr>
               <a:t>Mars 2026  |  Pipeline : Souris → Rat → Humain  |  Modèle Friberg et al.</a:t>
+            </a:r>
+          </a:p>
+        </p:txBody>
+      </p:sp>
+    </p:spTree>
+  </p:cSld>
+  <p:clrMapOvr>
+    <a:masterClrMapping/>
+  </p:clrMapOvr>
+</p:sld>
+</file>
+
+<file path=ppt/slides/slide8.xml><?xml version="1.0" encoding="utf-8"?>
+<p:sld xmlns:a="http://schemas.openxmlformats.org/drawingml/2006/main" xmlns:p="http://schemas.openxmlformats.org/presentationml/2006/main" xmlns:r="http://schemas.openxmlformats.org/officeDocument/2006/relationships">
+  <p:cSld>
+    <p:spTree>
+      <p:nvGrpSpPr>
+        <p:cNvPr id="1" name=""/>
+        <p:cNvGrpSpPr/>
+        <p:nvPr/>
+      </p:nvGrpSpPr>
+      <p:grpSpPr/>
+      <p:sp>
+        <p:nvSpPr>
+          <p:cNvPr id="2" name="Rectangle 1"/>
+          <p:cNvSpPr/>
+          <p:nvPr/>
+        </p:nvSpPr>
+        <p:spPr>
+          <a:xfrm>
+            <a:off x="0" y="0"/>
+            <a:ext cx="12188952" cy="540000"/>
+          </a:xfrm>
+          <a:prstGeom prst="rect">
+            <a:avLst/>
+          </a:prstGeom>
+          <a:solidFill>
+            <a:srgbClr val="1F497D"/>
+          </a:solidFill>
+          <a:ln>
+            <a:solidFill>
+              <a:srgbClr val="1F497D"/>
+            </a:solidFill>
+          </a:ln>
+        </p:spPr>
+        <p:style>
+          <a:lnRef idx="1">
+            <a:schemeClr val="accent1"/>
+          </a:lnRef>
+          <a:fillRef idx="3">
+            <a:schemeClr val="accent1"/>
+          </a:fillRef>
+          <a:effectRef idx="2">
+            <a:schemeClr val="accent1"/>
+          </a:effectRef>
+          <a:fontRef idx="minor">
+            <a:schemeClr val="lt1"/>
+          </a:fontRef>
+        </p:style>
+        <p:txBody>
+          <a:bodyPr rtlCol="0" anchor="ctr" wrap="none"/>
+          <a:lstStyle/>
+          <a:p>
+            <a:pPr algn="ctr"/>
+            <a:r>
+              <a:rPr sz="2000" b="1">
+                <a:solidFill>
+                  <a:srgbClr val="FFFFFF"/>
+                </a:solidFill>
+              </a:rPr>
+              <a:t>Adaptation du modèle Fornari : ce qu'on garde / ce qu'on remplace</a:t>
+            </a:r>
+          </a:p>
+        </p:txBody>
+      </p:sp>
+      <p:sp>
+        <p:nvSpPr>
+          <p:cNvPr id="3" name="Rectangle 2"/>
+          <p:cNvSpPr/>
+          <p:nvPr/>
+        </p:nvSpPr>
+        <p:spPr>
+          <a:xfrm>
+            <a:off x="180000" y="648000"/>
+            <a:ext cx="5842476" cy="396000"/>
+          </a:xfrm>
+          <a:prstGeom prst="rect">
+            <a:avLst/>
+          </a:prstGeom>
+          <a:solidFill>
+            <a:srgbClr val="00B050"/>
+          </a:solidFill>
+          <a:ln>
+            <a:solidFill>
+              <a:srgbClr val="00B050"/>
+            </a:solidFill>
+          </a:ln>
+        </p:spPr>
+        <p:style>
+          <a:lnRef idx="1">
+            <a:schemeClr val="accent1"/>
+          </a:lnRef>
+          <a:fillRef idx="3">
+            <a:schemeClr val="accent1"/>
+          </a:fillRef>
+          <a:effectRef idx="2">
+            <a:schemeClr val="accent1"/>
+          </a:effectRef>
+          <a:fontRef idx="minor">
+            <a:schemeClr val="lt1"/>
+          </a:fontRef>
+        </p:style>
+        <p:txBody>
+          <a:bodyPr rtlCol="0" anchor="ctr" wrap="none"/>
+          <a:lstStyle/>
+          <a:p>
+            <a:pPr algn="ctr"/>
+            <a:r>
+              <a:rPr sz="1500" b="1">
+                <a:solidFill>
+                  <a:srgbClr val="FFFFFF"/>
+                </a:solidFill>
+              </a:rPr>
+              <a:t>✅  Ce qu'on garde (Fornari)</a:t>
+            </a:r>
+          </a:p>
+        </p:txBody>
+      </p:sp>
+      <p:sp>
+        <p:nvSpPr>
+          <p:cNvPr id="5" name="Rectangle 4"/>
+          <p:cNvSpPr/>
+          <p:nvPr/>
+        </p:nvSpPr>
+        <p:spPr>
+          <a:xfrm>
+            <a:off x="180000" y="1098000"/>
+            <a:ext cx="5842476" cy="4896000"/>
+          </a:xfrm>
+          <a:prstGeom prst="rect">
+            <a:avLst/>
+          </a:prstGeom>
+          <a:solidFill>
+            <a:srgbClr val="E2EFDA"/>
+          </a:solidFill>
+          <a:ln w="12700">
+            <a:solidFill>
+              <a:srgbClr val="00B050"/>
+            </a:solidFill>
+          </a:ln>
+        </p:spPr>
+        <p:style>
+          <a:lnRef idx="1">
+            <a:schemeClr val="accent1"/>
+          </a:lnRef>
+          <a:fillRef idx="3">
+            <a:schemeClr val="accent1"/>
+          </a:fillRef>
+          <a:effectRef idx="2">
+            <a:schemeClr val="accent1"/>
+          </a:effectRef>
+          <a:fontRef idx="minor">
+            <a:schemeClr val="lt1"/>
+          </a:fontRef>
+        </p:style>
+        <p:txBody>
+          <a:bodyPr rtlCol="0" anchor="ctr" wrap="square"/>
+          <a:lstStyle/>
+          <a:p>
+            <a:pPr algn="l">
+              <a:spcBef>
+                <a:spcPts val="200"/>
+              </a:spcBef>
+              <a:spcAft>
+                <a:spcPts val="200"/>
+              </a:spcAft>
+            </a:pPr>
+            <a:r>
+              <a:rPr sz="1350" b="1">
+                <a:solidFill>
+                  <a:srgbClr val="1A5C1A"/>
+                </a:solidFill>
+              </a:rPr>
+              <a:t>• ODEs de l'hématopoïèse (compartiments 1–9)</a:t>
+            </a:r>
+          </a:p>
+          <a:p>
+            <a:pPr algn="l">
+              <a:spcBef>
+                <a:spcPts val="200"/>
+              </a:spcBef>
+              <a:spcAft>
+                <a:spcPts val="200"/>
+              </a:spcAft>
+            </a:pPr>
+            <a:r>
+              <a:rPr sz="1350" b="0">
+                <a:solidFill>
+                  <a:srgbClr val="000000"/>
+                </a:solidFill>
+              </a:rPr>
+              <a:t/>
+            </a:r>
+          </a:p>
+          <a:p>
+            <a:pPr algn="l">
+              <a:spcBef>
+                <a:spcPts val="200"/>
+              </a:spcBef>
+              <a:spcAft>
+                <a:spcPts val="200"/>
+              </a:spcAft>
+            </a:pPr>
+            <a:r>
+              <a:rPr sz="1350" b="1">
+                <a:solidFill>
+                  <a:srgbClr val="1A5C1A"/>
+                </a:solidFill>
+              </a:rPr>
+              <a:t>• Baselines :  Plt₀,  Neut₀,  Ret₀,  RBC₀</a:t>
+            </a:r>
+          </a:p>
+          <a:p>
+            <a:pPr algn="l">
+              <a:spcBef>
+                <a:spcPts val="200"/>
+              </a:spcBef>
+              <a:spcAft>
+                <a:spcPts val="200"/>
+              </a:spcAft>
+            </a:pPr>
+            <a:r>
+              <a:rPr sz="1350" b="0">
+                <a:solidFill>
+                  <a:srgbClr val="000000"/>
+                </a:solidFill>
+              </a:rPr>
+              <a:t/>
+            </a:r>
+          </a:p>
+          <a:p>
+            <a:pPr algn="l">
+              <a:spcBef>
+                <a:spcPts val="200"/>
+              </a:spcBef>
+              <a:spcAft>
+                <a:spcPts val="200"/>
+              </a:spcAft>
+            </a:pPr>
+            <a:r>
+              <a:rPr sz="1350" b="1">
+                <a:solidFill>
+                  <a:srgbClr val="1A5C1A"/>
+                </a:solidFill>
+              </a:rPr>
+              <a:t>• MTT_Plt = 168 h,  MTT_Neut = 210 h</a:t>
+            </a:r>
+          </a:p>
+          <a:p>
+            <a:pPr algn="l">
+              <a:spcBef>
+                <a:spcPts val="200"/>
+              </a:spcBef>
+              <a:spcAft>
+                <a:spcPts val="200"/>
+              </a:spcAft>
+            </a:pPr>
+            <a:r>
+              <a:rPr sz="1350" b="0">
+                <a:solidFill>
+                  <a:srgbClr val="000000"/>
+                </a:solidFill>
+              </a:rPr>
+              <a:t/>
+            </a:r>
+          </a:p>
+          <a:p>
+            <a:pPr algn="l">
+              <a:spcBef>
+                <a:spcPts val="200"/>
+              </a:spcBef>
+              <a:spcAft>
+                <a:spcPts val="200"/>
+              </a:spcAft>
+            </a:pPr>
+            <a:r>
+              <a:rPr sz="1350" b="1">
+                <a:solidFill>
+                  <a:srgbClr val="1A5C1A"/>
+                </a:solidFill>
+              </a:rPr>
+              <a:t>• Feedbacks γ  (mécanisme de régulation)</a:t>
+            </a:r>
+          </a:p>
+          <a:p>
+            <a:pPr algn="l">
+              <a:spcBef>
+                <a:spcPts val="200"/>
+              </a:spcBef>
+              <a:spcAft>
+                <a:spcPts val="200"/>
+              </a:spcAft>
+            </a:pPr>
+            <a:r>
+              <a:rPr sz="1350" b="0">
+                <a:solidFill>
+                  <a:srgbClr val="000000"/>
+                </a:solidFill>
+              </a:rPr>
+              <a:t/>
+            </a:r>
+          </a:p>
+          <a:p>
+            <a:pPr algn="l">
+              <a:spcBef>
+                <a:spcPts val="200"/>
+              </a:spcBef>
+              <a:spcAft>
+                <a:spcPts val="200"/>
+              </a:spcAft>
+            </a:pPr>
+            <a:r>
+              <a:rPr sz="1350" b="1">
+                <a:solidFill>
+                  <a:srgbClr val="1A5C1A"/>
+                </a:solidFill>
+              </a:rPr>
+              <a:t>• Grades NCI-CTCAE (toxicité hématologique)</a:t>
+            </a:r>
+          </a:p>
+        </p:txBody>
+      </p:sp>
+      <p:sp>
+        <p:nvSpPr>
+          <p:cNvPr id="6" name="Rectangle 5"/>
+          <p:cNvSpPr/>
+          <p:nvPr/>
+        </p:nvSpPr>
+        <p:spPr>
+          <a:xfrm>
+            <a:off x="6166476" y="648000"/>
+            <a:ext cx="5842476" cy="396000"/>
+          </a:xfrm>
+          <a:prstGeom prst="rect">
+            <a:avLst/>
+          </a:prstGeom>
+          <a:solidFill>
+            <a:srgbClr val="C00000"/>
+          </a:solidFill>
+          <a:ln>
+            <a:solidFill>
+              <a:srgbClr val="C00000"/>
+            </a:solidFill>
+          </a:ln>
+        </p:spPr>
+        <p:style>
+          <a:lnRef idx="1">
+            <a:schemeClr val="accent1"/>
+          </a:lnRef>
+          <a:fillRef idx="3">
+            <a:schemeClr val="accent1"/>
+          </a:fillRef>
+          <a:effectRef idx="2">
+            <a:schemeClr val="accent1"/>
+          </a:effectRef>
+          <a:fontRef idx="minor">
+            <a:schemeClr val="lt1"/>
+          </a:fontRef>
+        </p:style>
+        <p:txBody>
+          <a:bodyPr rtlCol="0" anchor="ctr" wrap="none"/>
+          <a:lstStyle/>
+          <a:p>
+            <a:pPr algn="ctr"/>
+            <a:r>
+              <a:rPr sz="1500" b="1">
+                <a:solidFill>
+                  <a:srgbClr val="FFFFFF"/>
+                </a:solidFill>
+              </a:rPr>
+              <a:t>❌  Ce qu'on remplace (ADC)</a:t>
+            </a:r>
+          </a:p>
+        </p:txBody>
+      </p:sp>
+      <p:sp>
+        <p:nvSpPr>
+          <p:cNvPr id="7" name="Rectangle 6"/>
+          <p:cNvSpPr/>
+          <p:nvPr/>
+        </p:nvSpPr>
+        <p:spPr>
+          <a:xfrm>
+            <a:off x="6166476" y="1098000"/>
+            <a:ext cx="5842476" cy="4896000"/>
+          </a:xfrm>
+          <a:prstGeom prst="rect">
+            <a:avLst/>
+          </a:prstGeom>
+          <a:solidFill>
+            <a:srgbClr val="FFE0E0"/>
+          </a:solidFill>
+          <a:ln w="12700">
+            <a:solidFill>
+              <a:srgbClr val="C00000"/>
+            </a:solidFill>
+          </a:ln>
+        </p:spPr>
+        <p:style>
+          <a:lnRef idx="1">
+            <a:schemeClr val="accent1"/>
+          </a:lnRef>
+          <a:fillRef idx="3">
+            <a:schemeClr val="accent1"/>
+          </a:fillRef>
+          <a:effectRef idx="2">
+            <a:schemeClr val="accent1"/>
+          </a:effectRef>
+          <a:fontRef idx="minor">
+            <a:schemeClr val="lt1"/>
+          </a:fontRef>
+        </p:style>
+        <p:txBody>
+          <a:bodyPr rtlCol="0" anchor="ctr" wrap="square"/>
+          <a:lstStyle/>
+          <a:p>
+            <a:pPr algn="l">
+              <a:spcBef>
+                <a:spcPts val="200"/>
+              </a:spcBef>
+              <a:spcAft>
+                <a:spcPts val="200"/>
+              </a:spcAft>
+            </a:pPr>
+            <a:r>
+              <a:rPr sz="1350" b="1" i="0">
+                <a:solidFill>
+                  <a:srgbClr val="8B0000"/>
+                </a:solidFill>
+              </a:rPr>
+              <a:t>• PK carboplatine  →  Cavg fixe  (pas de modèle PK)</a:t>
+            </a:r>
+          </a:p>
+          <a:p>
+            <a:pPr algn="l">
+              <a:spcBef>
+                <a:spcPts val="200"/>
+              </a:spcBef>
+              <a:spcAft>
+                <a:spcPts val="200"/>
+              </a:spcAft>
+            </a:pPr>
+            <a:r>
+              <a:rPr sz="1350" b="0" i="0">
+                <a:solidFill>
+                  <a:srgbClr val="444444"/>
+                </a:solidFill>
+              </a:rPr>
+              <a:t/>
+            </a:r>
+          </a:p>
+          <a:p>
+            <a:pPr algn="l">
+              <a:spcBef>
+                <a:spcPts val="200"/>
+              </a:spcBef>
+              <a:spcAft>
+                <a:spcPts val="200"/>
+              </a:spcAft>
+            </a:pPr>
+            <a:r>
+              <a:rPr sz="1350" b="1" i="0">
+                <a:solidFill>
+                  <a:srgbClr val="8B0000"/>
+                </a:solidFill>
+              </a:rPr>
+              <a:t>• Damage (adducts ADN)  →  Emax :</a:t>
+            </a:r>
+          </a:p>
+          <a:p>
+            <a:pPr algn="l">
+              <a:spcBef>
+                <a:spcPts val="200"/>
+              </a:spcBef>
+              <a:spcAft>
+                <a:spcPts val="200"/>
+              </a:spcAft>
+            </a:pPr>
+            <a:r>
+              <a:rPr sz="1350" b="0" i="1">
+                <a:solidFill>
+                  <a:srgbClr val="444444"/>
+                </a:solidFill>
+              </a:rPr>
+              <a:t>   Effect = Cavg / (IC50 + Cavg)</a:t>
+            </a:r>
+          </a:p>
+          <a:p>
+            <a:pPr algn="l">
+              <a:spcBef>
+                <a:spcPts val="200"/>
+              </a:spcBef>
+              <a:spcAft>
+                <a:spcPts val="200"/>
+              </a:spcAft>
+            </a:pPr>
+            <a:r>
+              <a:rPr sz="1350" b="0" i="0">
+                <a:solidFill>
+                  <a:srgbClr val="444444"/>
+                </a:solidFill>
+              </a:rPr>
+              <a:t/>
+            </a:r>
+          </a:p>
+          <a:p>
+            <a:pPr algn="l">
+              <a:spcBef>
+                <a:spcPts val="200"/>
+              </a:spcBef>
+              <a:spcAft>
+                <a:spcPts val="200"/>
+              </a:spcAft>
+            </a:pPr>
+            <a:r>
+              <a:rPr sz="1350" b="1" i="0">
+                <a:solidFill>
+                  <a:srgbClr val="8B0000"/>
+                </a:solidFill>
+              </a:rPr>
+              <a:t>• Slope / δ_Plt  →  à recalibrer avec données ADC</a:t>
+            </a:r>
+          </a:p>
+        </p:txBody>
+      </p:sp>
+      <p:sp>
+        <p:nvSpPr>
+          <p:cNvPr id="8" name="Rectangle 7"/>
+          <p:cNvSpPr/>
+          <p:nvPr/>
+        </p:nvSpPr>
+        <p:spPr>
+          <a:xfrm>
+            <a:off x="180000" y="6102000"/>
+            <a:ext cx="11828952" cy="576000"/>
+          </a:xfrm>
+          <a:prstGeom prst="rect">
+            <a:avLst/>
+          </a:prstGeom>
+          <a:solidFill>
+            <a:srgbClr val="FFFFCC"/>
+          </a:solidFill>
+          <a:ln w="19050">
+            <a:solidFill>
+              <a:srgbClr val="CCAA00"/>
+            </a:solidFill>
+          </a:ln>
+        </p:spPr>
+        <p:style>
+          <a:lnRef idx="1">
+            <a:schemeClr val="accent1"/>
+          </a:lnRef>
+          <a:fillRef idx="3">
+            <a:schemeClr val="accent1"/>
+          </a:fillRef>
+          <a:effectRef idx="2">
+            <a:schemeClr val="accent1"/>
+          </a:effectRef>
+          <a:fontRef idx="minor">
+            <a:schemeClr val="lt1"/>
+          </a:fontRef>
+        </p:style>
+        <p:txBody>
+          <a:bodyPr rtlCol="0" anchor="ctr" wrap="square"/>
+          <a:lstStyle/>
+          <a:p>
+            <a:pPr algn="ctr"/>
+            <a:r>
+              <a:rPr sz="1400" b="1" i="1">
+                <a:solidFill>
+                  <a:srgbClr val="7F6000"/>
+                </a:solidFill>
+              </a:rPr>
+              <a:t>Seul inconnu : Slope / Emax  →  estimation par analyse de sensibilité</a:t>
             </a:r>
           </a:p>
         </p:txBody>

</xml_diff>

<commit_message>
Fix slide 8: nettoie les doublons zip et refait la slide Fornari proprement
https://claude.ai/code/session_019UX7gxMosZJG12nhJXPH26
</commit_message>
<xml_diff>
--- a/reunion_point/reunion_prochaine.pptx
+++ b/reunion_point/reunion_prochaine.pptx
@@ -12,7 +12,7 @@
     <p:sldId id="260" r:id="rId11"/>
     <p:sldId id="261" r:id="rId12"/>
     <p:sldId id="262" r:id="rId13"/>
-    <p:sldId id="263" r:id="rId14"/>
+    <p:sldId id="263" r:id="rId15"/>
   </p:sldIdLst>
   <p:sldSz cx="12188952" cy="6858000" type="screen4x3"/>
   <p:notesSz cx="6858000" cy="9144000"/>
@@ -6713,7 +6713,7 @@
         <p:spPr>
           <a:xfrm>
             <a:off x="0" y="0"/>
-            <a:ext cx="12188952" cy="540000"/>
+            <a:ext cx="12188952" cy="576000"/>
           </a:xfrm>
           <a:prstGeom prst="rect">
             <a:avLst/>
@@ -6722,9 +6722,7 @@
             <a:srgbClr val="1F497D"/>
           </a:solidFill>
           <a:ln>
-            <a:solidFill>
-              <a:srgbClr val="1F497D"/>
-            </a:solidFill>
+            <a:noFill/>
           </a:ln>
         </p:spPr>
         <p:style>
@@ -6742,10 +6740,17 @@
           </a:fontRef>
         </p:style>
         <p:txBody>
-          <a:bodyPr rtlCol="0" anchor="ctr" wrap="none"/>
-          <a:lstStyle/>
-          <a:p>
-            <a:pPr algn="ctr"/>
+          <a:bodyPr rtlCol="0" anchor="ctr" wrap="square"/>
+          <a:lstStyle/>
+          <a:p>
+            <a:pPr algn="ctr">
+              <a:spcBef>
+                <a:spcPts val="300"/>
+              </a:spcBef>
+              <a:spcAft>
+                <a:spcPts val="300"/>
+              </a:spcAft>
+            </a:pPr>
             <a:r>
               <a:rPr sz="2000" b="1">
                 <a:solidFill>
@@ -6765,8 +6770,8 @@
         </p:nvSpPr>
         <p:spPr>
           <a:xfrm>
-            <a:off x="180000" y="648000"/>
-            <a:ext cx="5842476" cy="396000"/>
+            <a:off x="216000" y="720000"/>
+            <a:ext cx="5788476" cy="396000"/>
           </a:xfrm>
           <a:prstGeom prst="rect">
             <a:avLst/>
@@ -6775,9 +6780,7 @@
             <a:srgbClr val="00B050"/>
           </a:solidFill>
           <a:ln>
-            <a:solidFill>
-              <a:srgbClr val="00B050"/>
-            </a:solidFill>
+            <a:noFill/>
           </a:ln>
         </p:spPr>
         <p:style>
@@ -6795,31 +6798,38 @@
           </a:fontRef>
         </p:style>
         <p:txBody>
-          <a:bodyPr rtlCol="0" anchor="ctr" wrap="none"/>
-          <a:lstStyle/>
-          <a:p>
-            <a:pPr algn="ctr"/>
+          <a:bodyPr rtlCol="0" anchor="ctr" wrap="square"/>
+          <a:lstStyle/>
+          <a:p>
+            <a:pPr algn="ctr">
+              <a:spcBef>
+                <a:spcPts val="300"/>
+              </a:spcBef>
+              <a:spcAft>
+                <a:spcPts val="300"/>
+              </a:spcAft>
+            </a:pPr>
             <a:r>
               <a:rPr sz="1500" b="1">
                 <a:solidFill>
                   <a:srgbClr val="FFFFFF"/>
                 </a:solidFill>
               </a:rPr>
-              <a:t>✅  Ce qu'on garde (Fornari)</a:t>
-            </a:r>
-          </a:p>
-        </p:txBody>
-      </p:sp>
-      <p:sp>
-        <p:nvSpPr>
-          <p:cNvPr id="5" name="Rectangle 4"/>
+              <a:t>Ce qu'on garde (Fornari)</a:t>
+            </a:r>
+          </a:p>
+        </p:txBody>
+      </p:sp>
+      <p:sp>
+        <p:nvSpPr>
+          <p:cNvPr id="4" name="Rectangle 3"/>
           <p:cNvSpPr/>
           <p:nvPr/>
         </p:nvSpPr>
         <p:spPr>
           <a:xfrm>
-            <a:off x="180000" y="1098000"/>
-            <a:ext cx="5842476" cy="4896000"/>
+            <a:off x="216000" y="1152000"/>
+            <a:ext cx="5788476" cy="4806000"/>
           </a:xfrm>
           <a:prstGeom prst="rect">
             <a:avLst/>
@@ -6827,7 +6837,7 @@
           <a:solidFill>
             <a:srgbClr val="E2EFDA"/>
           </a:solidFill>
-          <a:ln w="12700">
+          <a:ln w="19050">
             <a:solidFill>
               <a:srgbClr val="00B050"/>
             </a:solidFill>
@@ -6853,177 +6863,105 @@
           <a:p>
             <a:pPr algn="l">
               <a:spcBef>
-                <a:spcPts val="200"/>
+                <a:spcPts val="300"/>
               </a:spcBef>
               <a:spcAft>
-                <a:spcPts val="200"/>
+                <a:spcPts val="300"/>
               </a:spcAft>
             </a:pPr>
             <a:r>
-              <a:rPr sz="1350" b="1">
+              <a:rPr sz="1300" b="1">
                 <a:solidFill>
                   <a:srgbClr val="1A5C1A"/>
                 </a:solidFill>
               </a:rPr>
-              <a:t>• ODEs de l'hématopoïèse (compartiments 1–9)</a:t>
+              <a:t>  ODEs de l'hématopoïèse (compartiments 1-9)</a:t>
             </a:r>
           </a:p>
           <a:p>
             <a:pPr algn="l">
               <a:spcBef>
-                <a:spcPts val="200"/>
+                <a:spcPts val="300"/>
               </a:spcBef>
               <a:spcAft>
-                <a:spcPts val="200"/>
+                <a:spcPts val="300"/>
               </a:spcAft>
             </a:pPr>
             <a:r>
-              <a:rPr sz="1350" b="0">
-                <a:solidFill>
-                  <a:srgbClr val="000000"/>
-                </a:solidFill>
-              </a:rPr>
-              <a:t/>
+              <a:rPr sz="1300" b="1">
+                <a:solidFill>
+                  <a:srgbClr val="1A5C1A"/>
+                </a:solidFill>
+              </a:rPr>
+              <a:t>  Baselines : Plt0, Neut0, Ret0, RBC0</a:t>
             </a:r>
           </a:p>
           <a:p>
             <a:pPr algn="l">
               <a:spcBef>
-                <a:spcPts val="200"/>
+                <a:spcPts val="300"/>
               </a:spcBef>
               <a:spcAft>
-                <a:spcPts val="200"/>
+                <a:spcPts val="300"/>
               </a:spcAft>
             </a:pPr>
             <a:r>
-              <a:rPr sz="1350" b="1">
+              <a:rPr sz="1300" b="1">
                 <a:solidFill>
                   <a:srgbClr val="1A5C1A"/>
                 </a:solidFill>
               </a:rPr>
-              <a:t>• Baselines :  Plt₀,  Neut₀,  Ret₀,  RBC₀</a:t>
+              <a:t>  MTT_Plt = 168 h,  MTT_Neut = 210 h</a:t>
             </a:r>
           </a:p>
           <a:p>
             <a:pPr algn="l">
               <a:spcBef>
-                <a:spcPts val="200"/>
+                <a:spcPts val="300"/>
               </a:spcBef>
               <a:spcAft>
-                <a:spcPts val="200"/>
+                <a:spcPts val="300"/>
               </a:spcAft>
             </a:pPr>
             <a:r>
-              <a:rPr sz="1350" b="0">
-                <a:solidFill>
-                  <a:srgbClr val="000000"/>
-                </a:solidFill>
-              </a:rPr>
-              <a:t/>
+              <a:rPr sz="1300" b="1">
+                <a:solidFill>
+                  <a:srgbClr val="1A5C1A"/>
+                </a:solidFill>
+              </a:rPr>
+              <a:t>  Feedbacks gamma (regulation)</a:t>
             </a:r>
           </a:p>
           <a:p>
             <a:pPr algn="l">
               <a:spcBef>
-                <a:spcPts val="200"/>
+                <a:spcPts val="300"/>
               </a:spcBef>
               <a:spcAft>
-                <a:spcPts val="200"/>
+                <a:spcPts val="300"/>
               </a:spcAft>
             </a:pPr>
             <a:r>
-              <a:rPr sz="1350" b="1">
+              <a:rPr sz="1300" b="1">
                 <a:solidFill>
                   <a:srgbClr val="1A5C1A"/>
                 </a:solidFill>
               </a:rPr>
-              <a:t>• MTT_Plt = 168 h,  MTT_Neut = 210 h</a:t>
-            </a:r>
-          </a:p>
-          <a:p>
-            <a:pPr algn="l">
-              <a:spcBef>
-                <a:spcPts val="200"/>
-              </a:spcBef>
-              <a:spcAft>
-                <a:spcPts val="200"/>
-              </a:spcAft>
-            </a:pPr>
-            <a:r>
-              <a:rPr sz="1350" b="0">
-                <a:solidFill>
-                  <a:srgbClr val="000000"/>
-                </a:solidFill>
-              </a:rPr>
-              <a:t/>
-            </a:r>
-          </a:p>
-          <a:p>
-            <a:pPr algn="l">
-              <a:spcBef>
-                <a:spcPts val="200"/>
-              </a:spcBef>
-              <a:spcAft>
-                <a:spcPts val="200"/>
-              </a:spcAft>
-            </a:pPr>
-            <a:r>
-              <a:rPr sz="1350" b="1">
-                <a:solidFill>
-                  <a:srgbClr val="1A5C1A"/>
-                </a:solidFill>
-              </a:rPr>
-              <a:t>• Feedbacks γ  (mécanisme de régulation)</a:t>
-            </a:r>
-          </a:p>
-          <a:p>
-            <a:pPr algn="l">
-              <a:spcBef>
-                <a:spcPts val="200"/>
-              </a:spcBef>
-              <a:spcAft>
-                <a:spcPts val="200"/>
-              </a:spcAft>
-            </a:pPr>
-            <a:r>
-              <a:rPr sz="1350" b="0">
-                <a:solidFill>
-                  <a:srgbClr val="000000"/>
-                </a:solidFill>
-              </a:rPr>
-              <a:t/>
-            </a:r>
-          </a:p>
-          <a:p>
-            <a:pPr algn="l">
-              <a:spcBef>
-                <a:spcPts val="200"/>
-              </a:spcBef>
-              <a:spcAft>
-                <a:spcPts val="200"/>
-              </a:spcAft>
-            </a:pPr>
-            <a:r>
-              <a:rPr sz="1350" b="1">
-                <a:solidFill>
-                  <a:srgbClr val="1A5C1A"/>
-                </a:solidFill>
-              </a:rPr>
-              <a:t>• Grades NCI-CTCAE (toxicité hématologique)</a:t>
-            </a:r>
-          </a:p>
-        </p:txBody>
-      </p:sp>
-      <p:sp>
-        <p:nvSpPr>
-          <p:cNvPr id="6" name="Rectangle 5"/>
+              <a:t>  Grades NCI-CTCAE (toxicite hemato)</a:t>
+            </a:r>
+          </a:p>
+        </p:txBody>
+      </p:sp>
+      <p:sp>
+        <p:nvSpPr>
+          <p:cNvPr id="5" name="Rectangle 4"/>
           <p:cNvSpPr/>
           <p:nvPr/>
         </p:nvSpPr>
         <p:spPr>
           <a:xfrm>
-            <a:off x="6166476" y="648000"/>
-            <a:ext cx="5842476" cy="396000"/>
+            <a:off x="6184476" y="720000"/>
+            <a:ext cx="5788476" cy="396000"/>
           </a:xfrm>
           <a:prstGeom prst="rect">
             <a:avLst/>
@@ -7032,9 +6970,7 @@
             <a:srgbClr val="C00000"/>
           </a:solidFill>
           <a:ln>
-            <a:solidFill>
-              <a:srgbClr val="C00000"/>
-            </a:solidFill>
+            <a:noFill/>
           </a:ln>
         </p:spPr>
         <p:style>
@@ -7052,31 +6988,38 @@
           </a:fontRef>
         </p:style>
         <p:txBody>
-          <a:bodyPr rtlCol="0" anchor="ctr" wrap="none"/>
-          <a:lstStyle/>
-          <a:p>
-            <a:pPr algn="ctr"/>
+          <a:bodyPr rtlCol="0" anchor="ctr" wrap="square"/>
+          <a:lstStyle/>
+          <a:p>
+            <a:pPr algn="ctr">
+              <a:spcBef>
+                <a:spcPts val="300"/>
+              </a:spcBef>
+              <a:spcAft>
+                <a:spcPts val="300"/>
+              </a:spcAft>
+            </a:pPr>
             <a:r>
               <a:rPr sz="1500" b="1">
                 <a:solidFill>
                   <a:srgbClr val="FFFFFF"/>
                 </a:solidFill>
               </a:rPr>
-              <a:t>❌  Ce qu'on remplace (ADC)</a:t>
-            </a:r>
-          </a:p>
-        </p:txBody>
-      </p:sp>
-      <p:sp>
-        <p:nvSpPr>
-          <p:cNvPr id="7" name="Rectangle 6"/>
+              <a:t>Ce qu'on remplace (ADC)</a:t>
+            </a:r>
+          </a:p>
+        </p:txBody>
+      </p:sp>
+      <p:sp>
+        <p:nvSpPr>
+          <p:cNvPr id="6" name="Rectangle 5"/>
           <p:cNvSpPr/>
           <p:nvPr/>
         </p:nvSpPr>
         <p:spPr>
           <a:xfrm>
-            <a:off x="6166476" y="1098000"/>
-            <a:ext cx="5842476" cy="4896000"/>
+            <a:off x="6184476" y="1152000"/>
+            <a:ext cx="5788476" cy="4806000"/>
           </a:xfrm>
           <a:prstGeom prst="rect">
             <a:avLst/>
@@ -7084,7 +7027,7 @@
           <a:solidFill>
             <a:srgbClr val="FFE0E0"/>
           </a:solidFill>
-          <a:ln w="12700">
+          <a:ln w="19050">
             <a:solidFill>
               <a:srgbClr val="C00000"/>
             </a:solidFill>
@@ -7110,123 +7053,123 @@
           <a:p>
             <a:pPr algn="l">
               <a:spcBef>
-                <a:spcPts val="200"/>
+                <a:spcPts val="300"/>
               </a:spcBef>
               <a:spcAft>
-                <a:spcPts val="200"/>
+                <a:spcPts val="300"/>
               </a:spcAft>
             </a:pPr>
             <a:r>
-              <a:rPr sz="1350" b="1" i="0">
+              <a:rPr sz="1300" b="1">
                 <a:solidFill>
                   <a:srgbClr val="8B0000"/>
                 </a:solidFill>
               </a:rPr>
-              <a:t>• PK carboplatine  →  Cavg fixe  (pas de modèle PK)</a:t>
+              <a:t>  PK carboplatine  -&gt;  Cavg fixe</a:t>
             </a:r>
           </a:p>
           <a:p>
             <a:pPr algn="l">
               <a:spcBef>
-                <a:spcPts val="200"/>
+                <a:spcPts val="300"/>
               </a:spcBef>
               <a:spcAft>
-                <a:spcPts val="200"/>
+                <a:spcPts val="300"/>
               </a:spcAft>
             </a:pPr>
             <a:r>
-              <a:rPr sz="1350" b="0" i="0">
+              <a:rPr sz="1100" b="0">
                 <a:solidFill>
                   <a:srgbClr val="444444"/>
                 </a:solidFill>
               </a:rPr>
-              <a:t/>
+              <a:t>    (pas de modele PK explicite)</a:t>
             </a:r>
           </a:p>
           <a:p>
             <a:pPr algn="l">
               <a:spcBef>
-                <a:spcPts val="200"/>
+                <a:spcPts val="300"/>
               </a:spcBef>
               <a:spcAft>
-                <a:spcPts val="200"/>
+                <a:spcPts val="300"/>
               </a:spcAft>
             </a:pPr>
             <a:r>
-              <a:rPr sz="1350" b="1" i="0">
+              <a:rPr sz="1300" b="1">
                 <a:solidFill>
                   <a:srgbClr val="8B0000"/>
                 </a:solidFill>
               </a:rPr>
-              <a:t>• Damage (adducts ADN)  →  Emax :</a:t>
+              <a:t>  Damage (adducts ADN)  -&gt;  Emax :</a:t>
             </a:r>
           </a:p>
           <a:p>
             <a:pPr algn="l">
               <a:spcBef>
-                <a:spcPts val="200"/>
+                <a:spcPts val="300"/>
               </a:spcBef>
               <a:spcAft>
-                <a:spcPts val="200"/>
+                <a:spcPts val="300"/>
               </a:spcAft>
             </a:pPr>
             <a:r>
-              <a:rPr sz="1350" b="0" i="1">
+              <a:rPr sz="1100" b="0">
                 <a:solidFill>
                   <a:srgbClr val="444444"/>
                 </a:solidFill>
               </a:rPr>
-              <a:t>   Effect = Cavg / (IC50 + Cavg)</a:t>
+              <a:t>    Effect = Cavg / (IC50 + Cavg)</a:t>
             </a:r>
           </a:p>
           <a:p>
             <a:pPr algn="l">
               <a:spcBef>
-                <a:spcPts val="200"/>
+                <a:spcPts val="300"/>
               </a:spcBef>
               <a:spcAft>
-                <a:spcPts val="200"/>
+                <a:spcPts val="300"/>
               </a:spcAft>
             </a:pPr>
             <a:r>
-              <a:rPr sz="1350" b="0" i="0">
-                <a:solidFill>
-                  <a:srgbClr val="444444"/>
-                </a:solidFill>
-              </a:rPr>
-              <a:t/>
+              <a:rPr sz="1300" b="1">
+                <a:solidFill>
+                  <a:srgbClr val="8B0000"/>
+                </a:solidFill>
+              </a:rPr>
+              <a:t>  Slope / delta_Plt  -&gt;  a recalibrer</a:t>
             </a:r>
           </a:p>
           <a:p>
             <a:pPr algn="l">
               <a:spcBef>
-                <a:spcPts val="200"/>
+                <a:spcPts val="300"/>
               </a:spcBef>
               <a:spcAft>
-                <a:spcPts val="200"/>
+                <a:spcPts val="300"/>
               </a:spcAft>
             </a:pPr>
             <a:r>
-              <a:rPr sz="1350" b="1" i="0">
-                <a:solidFill>
-                  <a:srgbClr val="8B0000"/>
-                </a:solidFill>
-              </a:rPr>
-              <a:t>• Slope / δ_Plt  →  à recalibrer avec données ADC</a:t>
-            </a:r>
-          </a:p>
-        </p:txBody>
-      </p:sp>
-      <p:sp>
-        <p:nvSpPr>
-          <p:cNvPr id="8" name="Rectangle 7"/>
+              <a:rPr sz="1100" b="0">
+                <a:solidFill>
+                  <a:srgbClr val="444444"/>
+                </a:solidFill>
+              </a:rPr>
+              <a:t>    avec donnees ADC</a:t>
+            </a:r>
+          </a:p>
+        </p:txBody>
+      </p:sp>
+      <p:sp>
+        <p:nvSpPr>
+          <p:cNvPr id="7" name="Rectangle 6"/>
           <p:cNvSpPr/>
           <p:nvPr/>
         </p:nvSpPr>
         <p:spPr>
           <a:xfrm>
-            <a:off x="180000" y="6102000"/>
-            <a:ext cx="11828952" cy="576000"/>
+            <a:off x="216000" y="6066000"/>
+            <a:ext cx="11756952" cy="576000"/>
           </a:xfrm>
           <a:prstGeom prst="rect">
             <a:avLst/>
@@ -7258,14 +7201,21 @@
           <a:bodyPr rtlCol="0" anchor="ctr" wrap="square"/>
           <a:lstStyle/>
           <a:p>
-            <a:pPr algn="ctr"/>
-            <a:r>
-              <a:rPr sz="1400" b="1" i="1">
+            <a:pPr algn="ctr">
+              <a:spcBef>
+                <a:spcPts val="300"/>
+              </a:spcBef>
+              <a:spcAft>
+                <a:spcPts val="300"/>
+              </a:spcAft>
+            </a:pPr>
+            <a:r>
+              <a:rPr sz="1400" b="1">
                 <a:solidFill>
                   <a:srgbClr val="7F6000"/>
                 </a:solidFill>
               </a:rPr>
-              <a:t>Seul inconnu : Slope / Emax  →  estimation par analyse de sensibilité</a:t>
+              <a:t>Seul inconnu : Slope / Emax  -&gt;  estimation par analyse de sensibilite</a:t>
             </a:r>
           </a:p>
         </p:txBody>

</xml_diff>